<commit_message>
Progress on generating CRN networks and TransferFunctions.
</commit_message>
<xml_diff>
--- a/docs/Generating LRI CRNs.pptx
+++ b/docs/Generating LRI CRNs.pptx
@@ -8,8 +8,9 @@
     <p:sldId id="256" r:id="rId2"/>
     <p:sldId id="257" r:id="rId3"/>
     <p:sldId id="258" r:id="rId4"/>
-    <p:sldId id="259" r:id="rId5"/>
-    <p:sldId id="260" r:id="rId6"/>
+    <p:sldId id="261" r:id="rId5"/>
+    <p:sldId id="259" r:id="rId6"/>
+    <p:sldId id="260" r:id="rId7"/>
   </p:sldIdLst>
   <p:sldSz cx="12192000" cy="6858000"/>
   <p:notesSz cx="6858000" cy="9144000"/>
@@ -263,7 +264,7 @@
           <a:p>
             <a:fld id="{B5C53FED-EFBD-5C48-A8B8-573DB367BA73}" type="datetimeFigureOut">
               <a:rPr lang="en-US" smtClean="0"/>
-              <a:t>11/19/25</a:t>
+              <a:t>11/20/25</a:t>
             </a:fld>
             <a:endParaRPr lang="en-US"/>
           </a:p>
@@ -461,7 +462,7 @@
           <a:p>
             <a:fld id="{B5C53FED-EFBD-5C48-A8B8-573DB367BA73}" type="datetimeFigureOut">
               <a:rPr lang="en-US" smtClean="0"/>
-              <a:t>11/19/25</a:t>
+              <a:t>11/20/25</a:t>
             </a:fld>
             <a:endParaRPr lang="en-US"/>
           </a:p>
@@ -669,7 +670,7 @@
           <a:p>
             <a:fld id="{B5C53FED-EFBD-5C48-A8B8-573DB367BA73}" type="datetimeFigureOut">
               <a:rPr lang="en-US" smtClean="0"/>
-              <a:t>11/19/25</a:t>
+              <a:t>11/20/25</a:t>
             </a:fld>
             <a:endParaRPr lang="en-US"/>
           </a:p>
@@ -867,7 +868,7 @@
           <a:p>
             <a:fld id="{B5C53FED-EFBD-5C48-A8B8-573DB367BA73}" type="datetimeFigureOut">
               <a:rPr lang="en-US" smtClean="0"/>
-              <a:t>11/19/25</a:t>
+              <a:t>11/20/25</a:t>
             </a:fld>
             <a:endParaRPr lang="en-US"/>
           </a:p>
@@ -1142,7 +1143,7 @@
           <a:p>
             <a:fld id="{B5C53FED-EFBD-5C48-A8B8-573DB367BA73}" type="datetimeFigureOut">
               <a:rPr lang="en-US" smtClean="0"/>
-              <a:t>11/19/25</a:t>
+              <a:t>11/20/25</a:t>
             </a:fld>
             <a:endParaRPr lang="en-US"/>
           </a:p>
@@ -1407,7 +1408,7 @@
           <a:p>
             <a:fld id="{B5C53FED-EFBD-5C48-A8B8-573DB367BA73}" type="datetimeFigureOut">
               <a:rPr lang="en-US" smtClean="0"/>
-              <a:t>11/19/25</a:t>
+              <a:t>11/20/25</a:t>
             </a:fld>
             <a:endParaRPr lang="en-US"/>
           </a:p>
@@ -1819,7 +1820,7 @@
           <a:p>
             <a:fld id="{B5C53FED-EFBD-5C48-A8B8-573DB367BA73}" type="datetimeFigureOut">
               <a:rPr lang="en-US" smtClean="0"/>
-              <a:t>11/19/25</a:t>
+              <a:t>11/20/25</a:t>
             </a:fld>
             <a:endParaRPr lang="en-US"/>
           </a:p>
@@ -1960,7 +1961,7 @@
           <a:p>
             <a:fld id="{B5C53FED-EFBD-5C48-A8B8-573DB367BA73}" type="datetimeFigureOut">
               <a:rPr lang="en-US" smtClean="0"/>
-              <a:t>11/19/25</a:t>
+              <a:t>11/20/25</a:t>
             </a:fld>
             <a:endParaRPr lang="en-US"/>
           </a:p>
@@ -2073,7 +2074,7 @@
           <a:p>
             <a:fld id="{B5C53FED-EFBD-5C48-A8B8-573DB367BA73}" type="datetimeFigureOut">
               <a:rPr lang="en-US" smtClean="0"/>
-              <a:t>11/19/25</a:t>
+              <a:t>11/20/25</a:t>
             </a:fld>
             <a:endParaRPr lang="en-US"/>
           </a:p>
@@ -2384,7 +2385,7 @@
           <a:p>
             <a:fld id="{B5C53FED-EFBD-5C48-A8B8-573DB367BA73}" type="datetimeFigureOut">
               <a:rPr lang="en-US" smtClean="0"/>
-              <a:t>11/19/25</a:t>
+              <a:t>11/20/25</a:t>
             </a:fld>
             <a:endParaRPr lang="en-US"/>
           </a:p>
@@ -2672,7 +2673,7 @@
           <a:p>
             <a:fld id="{B5C53FED-EFBD-5C48-A8B8-573DB367BA73}" type="datetimeFigureOut">
               <a:rPr lang="en-US" smtClean="0"/>
-              <a:t>11/19/25</a:t>
+              <a:t>11/20/25</a:t>
             </a:fld>
             <a:endParaRPr lang="en-US"/>
           </a:p>
@@ -2913,7 +2914,7 @@
           <a:p>
             <a:fld id="{B5C53FED-EFBD-5C48-A8B8-573DB367BA73}" type="datetimeFigureOut">
               <a:rPr lang="en-US" smtClean="0"/>
-              <a:t>11/19/25</a:t>
+              <a:t>11/20/25</a:t>
             </a:fld>
             <a:endParaRPr lang="en-US"/>
           </a:p>
@@ -3348,12 +3349,14 @@
         </p:nvSpPr>
         <p:spPr/>
         <p:txBody>
-          <a:bodyPr/>
+          <a:bodyPr>
+            <a:normAutofit fontScale="90000"/>
+          </a:bodyPr>
           <a:lstStyle/>
           <a:p>
             <a:r>
               <a:rPr lang="en-US" dirty="0"/>
-              <a:t>Transfer Functions for LTI SBML Models</a:t>
+              <a:t>Generating Stable LTI CRN Networks and Calculating Their Transfer Functions</a:t>
             </a:r>
           </a:p>
         </p:txBody>
@@ -3480,7 +3483,15 @@
           <a:p>
             <a:r>
               <a:rPr lang="en-US" dirty="0"/>
-              <a:t>Research direction: Use transfer functions to assess impact of couplings between CRN “modules” </a:t>
+              <a:t>Research direction: Use transfer functions to assess the impact of couplings between chemical reaction networks (</a:t>
+            </a:r>
+            <a:r>
+              <a:rPr lang="en-US" b="1" dirty="0"/>
+              <a:t>CRN</a:t>
+            </a:r>
+            <a:r>
+              <a:rPr lang="en-US" dirty="0"/>
+              <a:t>s)</a:t>
             </a:r>
           </a:p>
           <a:p>
@@ -3503,7 +3514,23 @@
             </a:pPr>
             <a:r>
               <a:rPr lang="en-US" dirty="0"/>
-              <a:t>Generate many examples of CRN that can be modeled as a Linear Time-Invariant (LTI) system</a:t>
+              <a:t>Generate </a:t>
+            </a:r>
+            <a:r>
+              <a:rPr lang="en-US" u="sng" dirty="0"/>
+              <a:t>stable</a:t>
+            </a:r>
+            <a:r>
+              <a:rPr lang="en-US" dirty="0"/>
+              <a:t> CRNs that can be modeled as a Linear Time-Invariant (</a:t>
+            </a:r>
+            <a:r>
+              <a:rPr lang="en-US" b="1" dirty="0"/>
+              <a:t>LTI</a:t>
+            </a:r>
+            <a:r>
+              <a:rPr lang="en-US" dirty="0"/>
+              <a:t>) system</a:t>
             </a:r>
           </a:p>
           <a:p>
@@ -3513,7 +3540,7 @@
             </a:pPr>
             <a:r>
               <a:rPr lang="en-US" dirty="0"/>
-              <a:t>Calculate the transfer function for generated CRNs</a:t>
+              <a:t>Calculate the transfer function of generated CRNs</a:t>
             </a:r>
           </a:p>
         </p:txBody>
@@ -3810,8 +3837,8 @@
           </a:p>
         </p:txBody>
       </p:sp>
-      <mc:AlternateContent xmlns:mc="http://schemas.openxmlformats.org/markup-compatibility/2006">
-        <mc:Choice xmlns:a14="http://schemas.microsoft.com/office/drawing/2010/main" Requires="a14">
+      <mc:AlternateContent xmlns:mc="http://schemas.openxmlformats.org/markup-compatibility/2006" xmlns:a14="http://schemas.microsoft.com/office/drawing/2010/main">
+        <mc:Choice Requires="a14">
           <p:sp>
             <p:nvSpPr>
               <p:cNvPr id="21" name="TextBox 20">
@@ -3840,6 +3867,7 @@
               </a:bodyPr>
               <a:lstStyle/>
               <a:p>
+                <a:pPr/>
                 <a14:m>
                   <m:oMathPara xmlns:m="http://schemas.openxmlformats.org/officeDocument/2006/math">
                     <m:oMathParaPr>
@@ -3860,7 +3888,7 @@
             </p:txBody>
           </p:sp>
         </mc:Choice>
-        <mc:Fallback>
+        <mc:Fallback xmlns="">
           <p:sp>
             <p:nvSpPr>
               <p:cNvPr id="21" name="TextBox 20">
@@ -4036,8 +4064,8 @@
               <a:chExt cx="2588914" cy="1066201"/>
             </a:xfrm>
           </p:grpSpPr>
-          <mc:AlternateContent xmlns:mc="http://schemas.openxmlformats.org/markup-compatibility/2006">
-            <mc:Choice xmlns:a14="http://schemas.microsoft.com/office/drawing/2010/main" Requires="a14">
+          <mc:AlternateContent xmlns:mc="http://schemas.openxmlformats.org/markup-compatibility/2006" xmlns:a14="http://schemas.microsoft.com/office/drawing/2010/main">
+            <mc:Choice Requires="a14">
               <p:sp>
                 <p:nvSpPr>
                   <p:cNvPr id="5" name="TextBox 4">
@@ -4066,6 +4094,7 @@
                   </a:bodyPr>
                   <a:lstStyle/>
                   <a:p>
+                    <a:pPr/>
                     <a14:m>
                       <m:oMathPara xmlns:m="http://schemas.openxmlformats.org/officeDocument/2006/math">
                         <m:oMathParaPr>
@@ -4241,7 +4270,7 @@
                 </p:txBody>
               </p:sp>
             </mc:Choice>
-            <mc:Fallback>
+            <mc:Fallback xmlns="">
               <p:sp>
                 <p:nvSpPr>
                   <p:cNvPr id="5" name="TextBox 4">
@@ -4286,8 +4315,8 @@
               </p:sp>
             </mc:Fallback>
           </mc:AlternateContent>
-          <mc:AlternateContent xmlns:mc="http://schemas.openxmlformats.org/markup-compatibility/2006">
-            <mc:Choice xmlns:a14="http://schemas.microsoft.com/office/drawing/2010/main" Requires="a14">
+          <mc:AlternateContent xmlns:mc="http://schemas.openxmlformats.org/markup-compatibility/2006" xmlns:a14="http://schemas.microsoft.com/office/drawing/2010/main">
+            <mc:Choice Requires="a14">
               <p:sp>
                 <p:nvSpPr>
                   <p:cNvPr id="6" name="TextBox 5">
@@ -4316,6 +4345,7 @@
                   </a:bodyPr>
                   <a:lstStyle/>
                   <a:p>
+                    <a:pPr/>
                     <a14:m>
                       <m:oMathPara xmlns:m="http://schemas.openxmlformats.org/officeDocument/2006/math">
                         <m:oMathParaPr>
@@ -4424,7 +4454,7 @@
                           <m:sSub>
                             <m:sSubPr>
                               <m:ctrlPr>
-                                <a:rPr lang="en-US" b="0" i="0" smtClean="0">
+                                <a:rPr lang="en-US" b="0" i="1" smtClean="0">
                                   <a:latin typeface="Cambria Math" panose="02040503050406030204" pitchFamily="18" charset="0"/>
                                 </a:rPr>
                               </m:ctrlPr>
@@ -4452,7 +4482,7 @@
                           <m:sSub>
                             <m:sSubPr>
                               <m:ctrlPr>
-                                <a:rPr lang="en-US" b="0" i="0" smtClean="0">
+                                <a:rPr lang="en-US" b="0" i="1" smtClean="0">
                                   <a:latin typeface="Cambria Math" panose="02040503050406030204" pitchFamily="18" charset="0"/>
                                 </a:rPr>
                               </m:ctrlPr>
@@ -4486,7 +4516,7 @@
                           <m:sSub>
                             <m:sSubPr>
                               <m:ctrlPr>
-                                <a:rPr lang="en-US" b="0" i="0" smtClean="0">
+                                <a:rPr lang="en-US" b="0" i="1" smtClean="0">
                                   <a:latin typeface="Cambria Math" panose="02040503050406030204" pitchFamily="18" charset="0"/>
                                 </a:rPr>
                               </m:ctrlPr>
@@ -4514,7 +4544,7 @@
                           <m:sSub>
                             <m:sSubPr>
                               <m:ctrlPr>
-                                <a:rPr lang="en-US" b="0" i="0" smtClean="0">
+                                <a:rPr lang="en-US" b="0" i="1" smtClean="0">
                                   <a:latin typeface="Cambria Math" panose="02040503050406030204" pitchFamily="18" charset="0"/>
                                 </a:rPr>
                               </m:ctrlPr>
@@ -4547,7 +4577,7 @@
                 </p:txBody>
               </p:sp>
             </mc:Choice>
-            <mc:Fallback>
+            <mc:Fallback xmlns="">
               <p:sp>
                 <p:nvSpPr>
                   <p:cNvPr id="6" name="TextBox 5">
@@ -4592,8 +4622,8 @@
               </p:sp>
             </mc:Fallback>
           </mc:AlternateContent>
-          <mc:AlternateContent xmlns:mc="http://schemas.openxmlformats.org/markup-compatibility/2006">
-            <mc:Choice xmlns:a14="http://schemas.microsoft.com/office/drawing/2010/main" Requires="a14">
+          <mc:AlternateContent xmlns:mc="http://schemas.openxmlformats.org/markup-compatibility/2006" xmlns:a14="http://schemas.microsoft.com/office/drawing/2010/main">
+            <mc:Choice Requires="a14">
               <p:sp>
                 <p:nvSpPr>
                   <p:cNvPr id="10" name="TextBox 9">
@@ -4622,6 +4652,7 @@
                   </a:bodyPr>
                   <a:lstStyle/>
                   <a:p>
+                    <a:pPr/>
                     <a14:m>
                       <m:oMathPara xmlns:m="http://schemas.openxmlformats.org/officeDocument/2006/math">
                         <m:oMathParaPr>
@@ -4758,7 +4789,7 @@
                 </p:txBody>
               </p:sp>
             </mc:Choice>
-            <mc:Fallback>
+            <mc:Fallback xmlns="">
               <p:sp>
                 <p:nvSpPr>
                   <p:cNvPr id="10" name="TextBox 9">
@@ -4936,8 +4967,8 @@
               <a:chExt cx="5273208" cy="984052"/>
             </a:xfrm>
           </p:grpSpPr>
-          <mc:AlternateContent xmlns:mc="http://schemas.openxmlformats.org/markup-compatibility/2006">
-            <mc:Choice xmlns:a14="http://schemas.microsoft.com/office/drawing/2010/main" Requires="a14">
+          <mc:AlternateContent xmlns:mc="http://schemas.openxmlformats.org/markup-compatibility/2006" xmlns:a14="http://schemas.microsoft.com/office/drawing/2010/main">
+            <mc:Choice Requires="a14">
               <p:sp>
                 <p:nvSpPr>
                   <p:cNvPr id="9" name="TextBox 8">
@@ -4966,6 +4997,7 @@
                   </a:bodyPr>
                   <a:lstStyle/>
                   <a:p>
+                    <a:pPr/>
                     <a14:m>
                       <m:oMathPara xmlns:m="http://schemas.openxmlformats.org/officeDocument/2006/math">
                         <m:oMathParaPr>
@@ -5252,7 +5284,7 @@
                 </p:txBody>
               </p:sp>
             </mc:Choice>
-            <mc:Fallback>
+            <mc:Fallback xmlns="">
               <p:sp>
                 <p:nvSpPr>
                   <p:cNvPr id="9" name="TextBox 8">
@@ -5297,8 +5329,8 @@
               </p:sp>
             </mc:Fallback>
           </mc:AlternateContent>
-          <mc:AlternateContent xmlns:mc="http://schemas.openxmlformats.org/markup-compatibility/2006">
-            <mc:Choice xmlns:a14="http://schemas.microsoft.com/office/drawing/2010/main" Requires="a14">
+          <mc:AlternateContent xmlns:mc="http://schemas.openxmlformats.org/markup-compatibility/2006" xmlns:a14="http://schemas.microsoft.com/office/drawing/2010/main">
+            <mc:Choice Requires="a14">
               <p:sp>
                 <p:nvSpPr>
                   <p:cNvPr id="13" name="TextBox 12">
@@ -5327,6 +5359,7 @@
                   </a:bodyPr>
                   <a:lstStyle/>
                   <a:p>
+                    <a:pPr/>
                     <a14:m>
                       <m:oMathPara xmlns:m="http://schemas.openxmlformats.org/officeDocument/2006/math">
                         <m:oMathParaPr>
@@ -5418,7 +5451,7 @@
                 </p:txBody>
               </p:sp>
             </mc:Choice>
-            <mc:Fallback>
+            <mc:Fallback xmlns="">
               <p:sp>
                 <p:nvSpPr>
                   <p:cNvPr id="13" name="TextBox 12">
@@ -5463,8 +5496,8 @@
               </p:sp>
             </mc:Fallback>
           </mc:AlternateContent>
-          <mc:AlternateContent xmlns:mc="http://schemas.openxmlformats.org/markup-compatibility/2006">
-            <mc:Choice xmlns:a14="http://schemas.microsoft.com/office/drawing/2010/main" Requires="a14">
+          <mc:AlternateContent xmlns:mc="http://schemas.openxmlformats.org/markup-compatibility/2006" xmlns:a14="http://schemas.microsoft.com/office/drawing/2010/main">
+            <mc:Choice Requires="a14">
               <p:sp>
                 <p:nvSpPr>
                   <p:cNvPr id="14" name="TextBox 13">
@@ -5493,6 +5526,7 @@
                   </a:bodyPr>
                   <a:lstStyle/>
                   <a:p>
+                    <a:pPr/>
                     <a14:m>
                       <m:oMathPara xmlns:m="http://schemas.openxmlformats.org/officeDocument/2006/math">
                         <m:oMathParaPr>
@@ -5691,7 +5725,7 @@
                 </p:txBody>
               </p:sp>
             </mc:Choice>
-            <mc:Fallback>
+            <mc:Fallback xmlns="">
               <p:sp>
                 <p:nvSpPr>
                   <p:cNvPr id="14" name="TextBox 13">
@@ -5736,8 +5770,8 @@
               </p:sp>
             </mc:Fallback>
           </mc:AlternateContent>
-          <mc:AlternateContent xmlns:mc="http://schemas.openxmlformats.org/markup-compatibility/2006">
-            <mc:Choice xmlns:a14="http://schemas.microsoft.com/office/drawing/2010/main" Requires="a14">
+          <mc:AlternateContent xmlns:mc="http://schemas.openxmlformats.org/markup-compatibility/2006" xmlns:a14="http://schemas.microsoft.com/office/drawing/2010/main">
+            <mc:Choice Requires="a14">
               <p:sp>
                 <p:nvSpPr>
                   <p:cNvPr id="16" name="TextBox 15">
@@ -5977,7 +6011,7 @@
                 </p:txBody>
               </p:sp>
             </mc:Choice>
-            <mc:Fallback>
+            <mc:Fallback xmlns="">
               <p:sp>
                 <p:nvSpPr>
                   <p:cNvPr id="16" name="TextBox 15">
@@ -6703,6 +6737,978 @@
           <p:cNvPr id="2" name="Title 1">
             <a:extLst>
               <a:ext uri="{FF2B5EF4-FFF2-40B4-BE49-F238E27FC236}">
+                <a16:creationId xmlns:a16="http://schemas.microsoft.com/office/drawing/2014/main" id="{C9AEAFA6-3A88-FAAE-DD8D-9842A0F1BFDE}"/>
+              </a:ext>
+            </a:extLst>
+          </p:cNvPr>
+          <p:cNvSpPr>
+            <a:spLocks noGrp="1"/>
+          </p:cNvSpPr>
+          <p:nvPr>
+            <p:ph type="title"/>
+          </p:nvPr>
+        </p:nvSpPr>
+        <p:spPr/>
+        <p:txBody>
+          <a:bodyPr/>
+          <a:lstStyle/>
+          <a:p>
+            <a:r>
+              <a:rPr lang="en-US" dirty="0"/>
+              <a:t>Ensuring Stability of a Generated CRN</a:t>
+            </a:r>
+          </a:p>
+        </p:txBody>
+      </p:sp>
+      <mc:AlternateContent xmlns:mc="http://schemas.openxmlformats.org/markup-compatibility/2006">
+        <mc:Choice xmlns:a14="http://schemas.microsoft.com/office/drawing/2010/main" Requires="a14">
+          <p:sp>
+            <p:nvSpPr>
+              <p:cNvPr id="3" name="Content Placeholder 2">
+                <a:extLst>
+                  <a:ext uri="{FF2B5EF4-FFF2-40B4-BE49-F238E27FC236}">
+                    <a16:creationId xmlns:a16="http://schemas.microsoft.com/office/drawing/2014/main" id="{C8E8FC6F-0D9F-BEEC-7866-B696816B64DD}"/>
+                  </a:ext>
+                </a:extLst>
+              </p:cNvPr>
+              <p:cNvSpPr>
+                <a:spLocks noGrp="1"/>
+              </p:cNvSpPr>
+              <p:nvPr>
+                <p:ph idx="1"/>
+              </p:nvPr>
+            </p:nvSpPr>
+            <p:spPr>
+              <a:xfrm>
+                <a:off x="838200" y="1471749"/>
+                <a:ext cx="10515600" cy="5021126"/>
+              </a:xfrm>
+            </p:spPr>
+            <p:txBody>
+              <a:bodyPr>
+                <a:normAutofit/>
+              </a:bodyPr>
+              <a:lstStyle/>
+              <a:p>
+                <a:r>
+                  <a:rPr lang="en-US" sz="2400" dirty="0"/>
+                  <a:t>All eigenvalues of the Jacobian must have their real part less than 0.</a:t>
+                </a:r>
+              </a:p>
+              <a:p>
+                <a:r>
+                  <a:rPr lang="en-US" sz="2400" dirty="0"/>
+                  <a:t>Intuition: For all species, degradation rate &gt; synthesis rate.</a:t>
+                </a:r>
+              </a:p>
+              <a:p>
+                <a:r>
+                  <a:rPr lang="en-US" sz="2400" b="1" dirty="0"/>
+                  <a:t>Gershgorin's Circle Theorem</a:t>
+                </a:r>
+              </a:p>
+              <a:p>
+                <a:pPr lvl="1"/>
+                <a:r>
+                  <a:rPr lang="en-US" sz="2000" dirty="0"/>
+                  <a:t>For an </a:t>
+                </a:r>
+                <a:r>
+                  <a:rPr lang="en-US" sz="2000" dirty="0" err="1"/>
+                  <a:t>n×n</a:t>
+                </a:r>
+                <a:r>
+                  <a:rPr lang="en-US" sz="2000" dirty="0"/>
+                  <a:t> matrix A with entries </a:t>
+                </a:r>
+                <a:r>
+                  <a:rPr lang="en-US" sz="2000" dirty="0" err="1"/>
+                  <a:t>a_ij</a:t>
+                </a:r>
+                <a:r>
+                  <a:rPr lang="en-US" sz="2000" dirty="0"/>
+                  <a:t>, every eigenvalue </a:t>
+                </a:r>
+                <a:r>
+                  <a:rPr lang="el-GR" sz="2000" dirty="0"/>
+                  <a:t>λ </a:t>
+                </a:r>
+                <a:r>
+                  <a:rPr lang="en-US" sz="2000" dirty="0"/>
+                  <a:t>of A lies within at least one of the </a:t>
+                </a:r>
+                <a:r>
+                  <a:rPr lang="en-US" sz="2000" b="1" dirty="0"/>
+                  <a:t>Gershgorin discs</a:t>
+                </a:r>
+                <a:r>
+                  <a:rPr lang="en-US" sz="2000" dirty="0"/>
+                  <a:t> </a:t>
+                </a:r>
+                <a:r>
+                  <a:rPr lang="en-US" sz="2000" dirty="0" err="1"/>
+                  <a:t>D_i</a:t>
+                </a:r>
+                <a:r>
+                  <a:rPr lang="en-US" sz="2000" dirty="0"/>
+                  <a:t>, where:</a:t>
+                </a:r>
+              </a:p>
+              <a:p>
+                <a:pPr lvl="1"/>
+                <a:r>
+                  <a:rPr lang="en-US" sz="2000" b="1" dirty="0" err="1"/>
+                  <a:t>D_i</a:t>
+                </a:r>
+                <a:r>
+                  <a:rPr lang="en-US" sz="2000" b="1" dirty="0"/>
+                  <a:t> = {z ∈ ℂ : |z - </a:t>
+                </a:r>
+                <a:r>
+                  <a:rPr lang="en-US" sz="2000" b="1" dirty="0" err="1"/>
+                  <a:t>a_ii</a:t>
+                </a:r>
+                <a:r>
+                  <a:rPr lang="en-US" sz="2000" b="1" dirty="0"/>
+                  <a:t>| ≤ </a:t>
+                </a:r>
+                <a:r>
+                  <a:rPr lang="en-US" sz="2000" b="1" dirty="0" err="1"/>
+                  <a:t>R_i</a:t>
+                </a:r>
+                <a:r>
+                  <a:rPr lang="en-US" sz="2000" b="1" dirty="0"/>
+                  <a:t>}</a:t>
+                </a:r>
+                <a:endParaRPr lang="en-US" sz="2000" dirty="0"/>
+              </a:p>
+              <a:p>
+                <a:pPr lvl="1"/>
+                <a:r>
+                  <a:rPr lang="en-US" sz="2000" dirty="0"/>
+                  <a:t>where:</a:t>
+                </a:r>
+              </a:p>
+              <a:p>
+                <a:pPr lvl="1"/>
+                <a:r>
+                  <a:rPr lang="en-US" sz="2000" b="1" dirty="0" err="1"/>
+                  <a:t>a_ii</a:t>
+                </a:r>
+                <a:r>
+                  <a:rPr lang="en-US" sz="2000" dirty="0"/>
+                  <a:t> is the </a:t>
+                </a:r>
+                <a:r>
+                  <a:rPr lang="en-US" sz="2000" dirty="0" err="1"/>
+                  <a:t>i-th</a:t>
+                </a:r>
+                <a:r>
+                  <a:rPr lang="en-US" sz="2000" dirty="0"/>
+                  <a:t> diagonal element (the center of the disc)</a:t>
+                </a:r>
+              </a:p>
+              <a:p>
+                <a:pPr lvl="1"/>
+                <a:r>
+                  <a:rPr lang="en-US" sz="2000" b="1" dirty="0" err="1"/>
+                  <a:t>R_i</a:t>
+                </a:r>
+                <a:r>
+                  <a:rPr lang="en-US" sz="2000" b="1" dirty="0"/>
+                  <a:t> = </a:t>
+                </a:r>
+                <a:r>
+                  <a:rPr lang="el-GR" sz="2000" b="1" dirty="0"/>
+                  <a:t>Σ_{</a:t>
+                </a:r>
+                <a:r>
+                  <a:rPr lang="en-US" sz="2000" b="1" dirty="0" err="1"/>
+                  <a:t>j≠i</a:t>
+                </a:r>
+                <a:r>
+                  <a:rPr lang="en-US" sz="2000" b="1" dirty="0"/>
+                  <a:t>} |</a:t>
+                </a:r>
+                <a:r>
+                  <a:rPr lang="en-US" sz="2000" b="1" dirty="0" err="1"/>
+                  <a:t>a_ij</a:t>
+                </a:r>
+                <a:r>
+                  <a:rPr lang="en-US" sz="2000" b="1" dirty="0"/>
+                  <a:t>|</a:t>
+                </a:r>
+                <a:r>
+                  <a:rPr lang="en-US" sz="2000" dirty="0"/>
+                  <a:t> is the sum of absolute values of off-diagonal elements in row </a:t>
+                </a:r>
+                <a:r>
+                  <a:rPr lang="en-US" sz="2000" dirty="0" err="1"/>
+                  <a:t>i</a:t>
+                </a:r>
+                <a:r>
+                  <a:rPr lang="en-US" sz="2000" dirty="0"/>
+                  <a:t> (the radius)</a:t>
+                </a:r>
+              </a:p>
+              <a:p>
+                <a:r>
+                  <a:rPr lang="en-US" sz="2400" dirty="0"/>
+                  <a:t>For each </a:t>
+                </a:r>
+                <a:r>
+                  <a:rPr lang="en-US" sz="2400" dirty="0">
+                    <a:latin typeface="Courier New" panose="02070309020205020404" pitchFamily="49" charset="0"/>
+                    <a:cs typeface="Courier New" panose="02070309020205020404" pitchFamily="49" charset="0"/>
+                  </a:rPr>
+                  <a:t>Sn</a:t>
+                </a:r>
+                <a:r>
+                  <a:rPr lang="en-US" sz="2400" dirty="0"/>
+                  <a:t>, add a degradation reaction if needed. Ex for </a:t>
+                </a:r>
+                <a:r>
+                  <a:rPr lang="en-US" sz="2400" dirty="0">
+                    <a:latin typeface="Courier New" panose="02070309020205020404" pitchFamily="49" charset="0"/>
+                    <a:cs typeface="Courier New" panose="02070309020205020404" pitchFamily="49" charset="0"/>
+                  </a:rPr>
+                  <a:t>S2</a:t>
+                </a:r>
+                <a:endParaRPr lang="en-US" sz="2400" dirty="0"/>
+              </a:p>
+              <a:p>
+                <a:pPr lvl="1"/>
+                <a14:m>
+                  <m:oMath xmlns:m="http://schemas.openxmlformats.org/officeDocument/2006/math">
+                    <m:sSub>
+                      <m:sSubPr>
+                        <m:ctrlPr>
+                          <a:rPr lang="en-US" sz="2000" b="0" i="1" smtClean="0">
+                            <a:latin typeface="Cambria Math" panose="02040503050406030204" pitchFamily="18" charset="0"/>
+                          </a:rPr>
+                        </m:ctrlPr>
+                      </m:sSubPr>
+                      <m:e>
+                        <m:r>
+                          <a:rPr lang="en-US" sz="2000" b="0" i="1" smtClean="0">
+                            <a:latin typeface="Cambria Math" panose="02040503050406030204" pitchFamily="18" charset="0"/>
+                          </a:rPr>
+                          <m:t>𝑘</m:t>
+                        </m:r>
+                      </m:e>
+                      <m:sub>
+                        <m:r>
+                          <a:rPr lang="en-US" sz="2000" b="0" i="1" smtClean="0">
+                            <a:latin typeface="Cambria Math" panose="02040503050406030204" pitchFamily="18" charset="0"/>
+                          </a:rPr>
+                          <m:t>3</m:t>
+                        </m:r>
+                      </m:sub>
+                    </m:sSub>
+                    <m:r>
+                      <a:rPr lang="en-US" sz="2000" b="0" i="1" smtClean="0">
+                        <a:latin typeface="Cambria Math" panose="02040503050406030204" pitchFamily="18" charset="0"/>
+                      </a:rPr>
+                      <m:t>+</m:t>
+                    </m:r>
+                    <m:sSub>
+                      <m:sSubPr>
+                        <m:ctrlPr>
+                          <a:rPr lang="en-US" sz="2000" b="0" i="1" smtClean="0">
+                            <a:latin typeface="Cambria Math" panose="02040503050406030204" pitchFamily="18" charset="0"/>
+                          </a:rPr>
+                        </m:ctrlPr>
+                      </m:sSubPr>
+                      <m:e>
+                        <m:r>
+                          <a:rPr lang="en-US" sz="2000" b="0" i="1" smtClean="0">
+                            <a:latin typeface="Cambria Math" panose="02040503050406030204" pitchFamily="18" charset="0"/>
+                          </a:rPr>
+                          <m:t>𝑘</m:t>
+                        </m:r>
+                      </m:e>
+                      <m:sub>
+                        <m:r>
+                          <a:rPr lang="en-US" sz="2000" b="0" i="1" smtClean="0">
+                            <a:latin typeface="Cambria Math" panose="02040503050406030204" pitchFamily="18" charset="0"/>
+                          </a:rPr>
+                          <m:t>4</m:t>
+                        </m:r>
+                      </m:sub>
+                    </m:sSub>
+                    <m:r>
+                      <a:rPr lang="en-US" sz="2000" b="0" i="1" smtClean="0">
+                        <a:latin typeface="Cambria Math" panose="02040503050406030204" pitchFamily="18" charset="0"/>
+                      </a:rPr>
+                      <m:t>−2</m:t>
+                    </m:r>
+                    <m:sSub>
+                      <m:sSubPr>
+                        <m:ctrlPr>
+                          <a:rPr lang="en-US" sz="2000" b="0" i="1" smtClean="0">
+                            <a:latin typeface="Cambria Math" panose="02040503050406030204" pitchFamily="18" charset="0"/>
+                          </a:rPr>
+                        </m:ctrlPr>
+                      </m:sSubPr>
+                      <m:e>
+                        <m:r>
+                          <a:rPr lang="en-US" sz="2000" b="0" i="1" smtClean="0">
+                            <a:latin typeface="Cambria Math" panose="02040503050406030204" pitchFamily="18" charset="0"/>
+                          </a:rPr>
+                          <m:t>𝑘</m:t>
+                        </m:r>
+                      </m:e>
+                      <m:sub>
+                        <m:r>
+                          <a:rPr lang="en-US" sz="2000" b="0" i="1" smtClean="0">
+                            <a:latin typeface="Cambria Math" panose="02040503050406030204" pitchFamily="18" charset="0"/>
+                          </a:rPr>
+                          <m:t>2</m:t>
+                        </m:r>
+                      </m:sub>
+                    </m:sSub>
+                    <m:r>
+                      <a:rPr lang="en-US" sz="2000" b="0" i="1" smtClean="0">
+                        <a:latin typeface="Cambria Math" panose="02040503050406030204" pitchFamily="18" charset="0"/>
+                      </a:rPr>
+                      <m:t>−</m:t>
+                    </m:r>
+                    <m:sSub>
+                      <m:sSubPr>
+                        <m:ctrlPr>
+                          <a:rPr lang="en-US" sz="2000" b="0" i="1" smtClean="0">
+                            <a:latin typeface="Cambria Math" panose="02040503050406030204" pitchFamily="18" charset="0"/>
+                          </a:rPr>
+                        </m:ctrlPr>
+                      </m:sSubPr>
+                      <m:e>
+                        <m:r>
+                          <a:rPr lang="en-US" sz="2000" b="0" i="1" smtClean="0">
+                            <a:latin typeface="Cambria Math" panose="02040503050406030204" pitchFamily="18" charset="0"/>
+                          </a:rPr>
+                          <m:t>𝑘</m:t>
+                        </m:r>
+                      </m:e>
+                      <m:sub>
+                        <m:r>
+                          <a:rPr lang="en-US" sz="2000" b="0" i="1" smtClean="0">
+                            <a:latin typeface="Cambria Math" panose="02040503050406030204" pitchFamily="18" charset="0"/>
+                          </a:rPr>
+                          <m:t>3</m:t>
+                        </m:r>
+                      </m:sub>
+                    </m:sSub>
+                    <m:r>
+                      <a:rPr lang="en-US" sz="2000" b="0" i="1" smtClean="0">
+                        <a:latin typeface="Cambria Math" panose="02040503050406030204" pitchFamily="18" charset="0"/>
+                      </a:rPr>
+                      <m:t>=</m:t>
+                    </m:r>
+                    <m:sSub>
+                      <m:sSubPr>
+                        <m:ctrlPr>
+                          <a:rPr lang="en-US" sz="2000" b="0" i="1" smtClean="0">
+                            <a:latin typeface="Cambria Math" panose="02040503050406030204" pitchFamily="18" charset="0"/>
+                          </a:rPr>
+                        </m:ctrlPr>
+                      </m:sSubPr>
+                      <m:e>
+                        <m:r>
+                          <a:rPr lang="en-US" sz="2000" b="0" i="1" smtClean="0">
+                            <a:latin typeface="Cambria Math" panose="02040503050406030204" pitchFamily="18" charset="0"/>
+                          </a:rPr>
+                          <m:t>𝑘</m:t>
+                        </m:r>
+                      </m:e>
+                      <m:sub>
+                        <m:r>
+                          <a:rPr lang="en-US" sz="2000" b="0" i="1" smtClean="0">
+                            <a:latin typeface="Cambria Math" panose="02040503050406030204" pitchFamily="18" charset="0"/>
+                          </a:rPr>
+                          <m:t>4</m:t>
+                        </m:r>
+                      </m:sub>
+                    </m:sSub>
+                    <m:r>
+                      <a:rPr lang="en-US" sz="2000" b="0" i="1" smtClean="0">
+                        <a:latin typeface="Cambria Math" panose="02040503050406030204" pitchFamily="18" charset="0"/>
+                      </a:rPr>
+                      <m:t>−2</m:t>
+                    </m:r>
+                    <m:sSub>
+                      <m:sSubPr>
+                        <m:ctrlPr>
+                          <a:rPr lang="en-US" sz="2000" b="0" i="1" smtClean="0">
+                            <a:latin typeface="Cambria Math" panose="02040503050406030204" pitchFamily="18" charset="0"/>
+                          </a:rPr>
+                        </m:ctrlPr>
+                      </m:sSubPr>
+                      <m:e>
+                        <m:r>
+                          <a:rPr lang="en-US" sz="2000" b="0" i="1" smtClean="0">
+                            <a:latin typeface="Cambria Math" panose="02040503050406030204" pitchFamily="18" charset="0"/>
+                          </a:rPr>
+                          <m:t>𝑘</m:t>
+                        </m:r>
+                      </m:e>
+                      <m:sub>
+                        <m:r>
+                          <a:rPr lang="en-US" sz="2000" b="0" i="1" smtClean="0">
+                            <a:latin typeface="Cambria Math" panose="02040503050406030204" pitchFamily="18" charset="0"/>
+                          </a:rPr>
+                          <m:t>2</m:t>
+                        </m:r>
+                      </m:sub>
+                    </m:sSub>
+                  </m:oMath>
+                </a14:m>
+                <a:r>
+                  <a:rPr lang="en-US" sz="2000" dirty="0"/>
+                  <a:t> </a:t>
+                </a:r>
+              </a:p>
+              <a:p>
+                <a:pPr lvl="1"/>
+                <a:r>
+                  <a:rPr lang="en-US" sz="2000" dirty="0"/>
+                  <a:t>Add reaction: </a:t>
+                </a:r>
+                <a:r>
+                  <a:rPr lang="en-US" sz="2000" dirty="0">
+                    <a:latin typeface="Courier New" panose="02070309020205020404" pitchFamily="49" charset="0"/>
+                    <a:cs typeface="Courier New" panose="02070309020205020404" pitchFamily="49" charset="0"/>
+                  </a:rPr>
+                  <a:t>S2 -&gt; ; (k4 – 2k2 + 0.1)*S2</a:t>
+                </a:r>
+              </a:p>
+              <a:p>
+                <a:pPr lvl="1"/>
+                <a:endParaRPr lang="en-US" sz="2000" dirty="0"/>
+              </a:p>
+            </p:txBody>
+          </p:sp>
+        </mc:Choice>
+        <mc:Fallback>
+          <p:sp>
+            <p:nvSpPr>
+              <p:cNvPr id="3" name="Content Placeholder 2">
+                <a:extLst>
+                  <a:ext uri="{FF2B5EF4-FFF2-40B4-BE49-F238E27FC236}">
+                    <a16:creationId xmlns:a16="http://schemas.microsoft.com/office/drawing/2014/main" id="{C8E8FC6F-0D9F-BEEC-7866-B696816B64DD}"/>
+                  </a:ext>
+                </a:extLst>
+              </p:cNvPr>
+              <p:cNvSpPr>
+                <a:spLocks noGrp="1" noRot="1" noChangeAspect="1" noMove="1" noResize="1" noEditPoints="1" noAdjustHandles="1" noChangeArrowheads="1" noChangeShapeType="1" noTextEdit="1"/>
+              </p:cNvSpPr>
+              <p:nvPr>
+                <p:ph idx="1"/>
+              </p:nvPr>
+            </p:nvSpPr>
+            <p:spPr>
+              <a:xfrm>
+                <a:off x="838200" y="1471749"/>
+                <a:ext cx="10515600" cy="5021126"/>
+              </a:xfrm>
+              <a:blipFill>
+                <a:blip r:embed="rId2"/>
+                <a:stretch>
+                  <a:fillRect l="-844" t="-1511" r="-241"/>
+                </a:stretch>
+              </a:blipFill>
+            </p:spPr>
+            <p:txBody>
+              <a:bodyPr/>
+              <a:lstStyle/>
+              <a:p>
+                <a:r>
+                  <a:rPr lang="en-US">
+                    <a:noFill/>
+                  </a:rPr>
+                  <a:t> </a:t>
+                </a:r>
+              </a:p>
+            </p:txBody>
+          </p:sp>
+        </mc:Fallback>
+      </mc:AlternateContent>
+      <p:pic>
+        <p:nvPicPr>
+          <p:cNvPr id="4" name="Picture 3">
+            <a:extLst>
+              <a:ext uri="{FF2B5EF4-FFF2-40B4-BE49-F238E27FC236}">
+                <a16:creationId xmlns:a16="http://schemas.microsoft.com/office/drawing/2014/main" id="{F464C9AC-E1B9-CD92-0B88-ECC6BD497FFF}"/>
+              </a:ext>
+            </a:extLst>
+          </p:cNvPr>
+          <p:cNvPicPr>
+            <a:picLocks noChangeAspect="1"/>
+          </p:cNvPicPr>
+          <p:nvPr/>
+        </p:nvPicPr>
+        <p:blipFill>
+          <a:blip r:embed="rId3"/>
+          <a:stretch>
+            <a:fillRect/>
+          </a:stretch>
+        </p:blipFill>
+        <p:spPr>
+          <a:xfrm>
+            <a:off x="10083800" y="272245"/>
+            <a:ext cx="1530350" cy="1383474"/>
+          </a:xfrm>
+          <a:prstGeom prst="rect">
+            <a:avLst/>
+          </a:prstGeom>
+        </p:spPr>
+      </p:pic>
+    </p:spTree>
+    <p:extLst>
+      <p:ext uri="{BB962C8B-B14F-4D97-AF65-F5344CB8AC3E}">
+        <p14:creationId xmlns:p14="http://schemas.microsoft.com/office/powerpoint/2010/main" val="1809028938"/>
+      </p:ext>
+    </p:extLst>
+  </p:cSld>
+  <p:clrMapOvr>
+    <a:masterClrMapping/>
+  </p:clrMapOvr>
+  <p:timing>
+    <p:tnLst>
+      <p:par>
+        <p:cTn id="1" dur="indefinite" restart="never" nodeType="tmRoot">
+          <p:childTnLst>
+            <p:seq concurrent="1" nextAc="seek">
+              <p:cTn id="2" dur="indefinite" nodeType="mainSeq">
+                <p:childTnLst>
+                  <p:par>
+                    <p:cTn id="3" fill="hold">
+                      <p:stCondLst>
+                        <p:cond delay="indefinite"/>
+                      </p:stCondLst>
+                      <p:childTnLst>
+                        <p:par>
+                          <p:cTn id="4" fill="hold">
+                            <p:stCondLst>
+                              <p:cond delay="0"/>
+                            </p:stCondLst>
+                            <p:childTnLst>
+                              <p:par>
+                                <p:cTn id="5" presetID="1" presetClass="entr" presetSubtype="0" fill="hold" nodeType="clickEffect">
+                                  <p:stCondLst>
+                                    <p:cond delay="0"/>
+                                  </p:stCondLst>
+                                  <p:childTnLst>
+                                    <p:set>
+                                      <p:cBhvr>
+                                        <p:cTn id="6" dur="1" fill="hold">
+                                          <p:stCondLst>
+                                            <p:cond delay="0"/>
+                                          </p:stCondLst>
+                                        </p:cTn>
+                                        <p:tgtEl>
+                                          <p:spTgt spid="3">
+                                            <p:txEl>
+                                              <p:pRg st="1" end="1"/>
+                                            </p:txEl>
+                                          </p:spTgt>
+                                        </p:tgtEl>
+                                        <p:attrNameLst>
+                                          <p:attrName>style.visibility</p:attrName>
+                                        </p:attrNameLst>
+                                      </p:cBhvr>
+                                      <p:to>
+                                        <p:strVal val="visible"/>
+                                      </p:to>
+                                    </p:set>
+                                  </p:childTnLst>
+                                </p:cTn>
+                              </p:par>
+                            </p:childTnLst>
+                          </p:cTn>
+                        </p:par>
+                      </p:childTnLst>
+                    </p:cTn>
+                  </p:par>
+                  <p:par>
+                    <p:cTn id="7" fill="hold">
+                      <p:stCondLst>
+                        <p:cond delay="indefinite"/>
+                      </p:stCondLst>
+                      <p:childTnLst>
+                        <p:par>
+                          <p:cTn id="8" fill="hold">
+                            <p:stCondLst>
+                              <p:cond delay="0"/>
+                            </p:stCondLst>
+                            <p:childTnLst>
+                              <p:par>
+                                <p:cTn id="9" presetID="1" presetClass="entr" presetSubtype="0" fill="hold" nodeType="clickEffect">
+                                  <p:stCondLst>
+                                    <p:cond delay="0"/>
+                                  </p:stCondLst>
+                                  <p:childTnLst>
+                                    <p:set>
+                                      <p:cBhvr>
+                                        <p:cTn id="10" dur="1" fill="hold">
+                                          <p:stCondLst>
+                                            <p:cond delay="0"/>
+                                          </p:stCondLst>
+                                        </p:cTn>
+                                        <p:tgtEl>
+                                          <p:spTgt spid="3">
+                                            <p:txEl>
+                                              <p:pRg st="2" end="2"/>
+                                            </p:txEl>
+                                          </p:spTgt>
+                                        </p:tgtEl>
+                                        <p:attrNameLst>
+                                          <p:attrName>style.visibility</p:attrName>
+                                        </p:attrNameLst>
+                                      </p:cBhvr>
+                                      <p:to>
+                                        <p:strVal val="visible"/>
+                                      </p:to>
+                                    </p:set>
+                                  </p:childTnLst>
+                                </p:cTn>
+                              </p:par>
+                              <p:par>
+                                <p:cTn id="11" presetID="1" presetClass="entr" presetSubtype="0" fill="hold" nodeType="withEffect">
+                                  <p:stCondLst>
+                                    <p:cond delay="0"/>
+                                  </p:stCondLst>
+                                  <p:childTnLst>
+                                    <p:set>
+                                      <p:cBhvr>
+                                        <p:cTn id="12" dur="1" fill="hold">
+                                          <p:stCondLst>
+                                            <p:cond delay="0"/>
+                                          </p:stCondLst>
+                                        </p:cTn>
+                                        <p:tgtEl>
+                                          <p:spTgt spid="3">
+                                            <p:txEl>
+                                              <p:pRg st="3" end="3"/>
+                                            </p:txEl>
+                                          </p:spTgt>
+                                        </p:tgtEl>
+                                        <p:attrNameLst>
+                                          <p:attrName>style.visibility</p:attrName>
+                                        </p:attrNameLst>
+                                      </p:cBhvr>
+                                      <p:to>
+                                        <p:strVal val="visible"/>
+                                      </p:to>
+                                    </p:set>
+                                  </p:childTnLst>
+                                </p:cTn>
+                              </p:par>
+                              <p:par>
+                                <p:cTn id="13" presetID="1" presetClass="entr" presetSubtype="0" fill="hold" nodeType="withEffect">
+                                  <p:stCondLst>
+                                    <p:cond delay="0"/>
+                                  </p:stCondLst>
+                                  <p:childTnLst>
+                                    <p:set>
+                                      <p:cBhvr>
+                                        <p:cTn id="14" dur="1" fill="hold">
+                                          <p:stCondLst>
+                                            <p:cond delay="0"/>
+                                          </p:stCondLst>
+                                        </p:cTn>
+                                        <p:tgtEl>
+                                          <p:spTgt spid="3">
+                                            <p:txEl>
+                                              <p:pRg st="4" end="4"/>
+                                            </p:txEl>
+                                          </p:spTgt>
+                                        </p:tgtEl>
+                                        <p:attrNameLst>
+                                          <p:attrName>style.visibility</p:attrName>
+                                        </p:attrNameLst>
+                                      </p:cBhvr>
+                                      <p:to>
+                                        <p:strVal val="visible"/>
+                                      </p:to>
+                                    </p:set>
+                                  </p:childTnLst>
+                                </p:cTn>
+                              </p:par>
+                              <p:par>
+                                <p:cTn id="15" presetID="1" presetClass="entr" presetSubtype="0" fill="hold" nodeType="withEffect">
+                                  <p:stCondLst>
+                                    <p:cond delay="0"/>
+                                  </p:stCondLst>
+                                  <p:childTnLst>
+                                    <p:set>
+                                      <p:cBhvr>
+                                        <p:cTn id="16" dur="1" fill="hold">
+                                          <p:stCondLst>
+                                            <p:cond delay="0"/>
+                                          </p:stCondLst>
+                                        </p:cTn>
+                                        <p:tgtEl>
+                                          <p:spTgt spid="3">
+                                            <p:txEl>
+                                              <p:pRg st="5" end="5"/>
+                                            </p:txEl>
+                                          </p:spTgt>
+                                        </p:tgtEl>
+                                        <p:attrNameLst>
+                                          <p:attrName>style.visibility</p:attrName>
+                                        </p:attrNameLst>
+                                      </p:cBhvr>
+                                      <p:to>
+                                        <p:strVal val="visible"/>
+                                      </p:to>
+                                    </p:set>
+                                  </p:childTnLst>
+                                </p:cTn>
+                              </p:par>
+                              <p:par>
+                                <p:cTn id="17" presetID="1" presetClass="entr" presetSubtype="0" fill="hold" nodeType="withEffect">
+                                  <p:stCondLst>
+                                    <p:cond delay="0"/>
+                                  </p:stCondLst>
+                                  <p:childTnLst>
+                                    <p:set>
+                                      <p:cBhvr>
+                                        <p:cTn id="18" dur="1" fill="hold">
+                                          <p:stCondLst>
+                                            <p:cond delay="0"/>
+                                          </p:stCondLst>
+                                        </p:cTn>
+                                        <p:tgtEl>
+                                          <p:spTgt spid="3">
+                                            <p:txEl>
+                                              <p:pRg st="6" end="6"/>
+                                            </p:txEl>
+                                          </p:spTgt>
+                                        </p:tgtEl>
+                                        <p:attrNameLst>
+                                          <p:attrName>style.visibility</p:attrName>
+                                        </p:attrNameLst>
+                                      </p:cBhvr>
+                                      <p:to>
+                                        <p:strVal val="visible"/>
+                                      </p:to>
+                                    </p:set>
+                                  </p:childTnLst>
+                                </p:cTn>
+                              </p:par>
+                              <p:par>
+                                <p:cTn id="19" presetID="1" presetClass="entr" presetSubtype="0" fill="hold" nodeType="withEffect">
+                                  <p:stCondLst>
+                                    <p:cond delay="0"/>
+                                  </p:stCondLst>
+                                  <p:childTnLst>
+                                    <p:set>
+                                      <p:cBhvr>
+                                        <p:cTn id="20" dur="1" fill="hold">
+                                          <p:stCondLst>
+                                            <p:cond delay="0"/>
+                                          </p:stCondLst>
+                                        </p:cTn>
+                                        <p:tgtEl>
+                                          <p:spTgt spid="3">
+                                            <p:txEl>
+                                              <p:pRg st="7" end="7"/>
+                                            </p:txEl>
+                                          </p:spTgt>
+                                        </p:tgtEl>
+                                        <p:attrNameLst>
+                                          <p:attrName>style.visibility</p:attrName>
+                                        </p:attrNameLst>
+                                      </p:cBhvr>
+                                      <p:to>
+                                        <p:strVal val="visible"/>
+                                      </p:to>
+                                    </p:set>
+                                  </p:childTnLst>
+                                </p:cTn>
+                              </p:par>
+                            </p:childTnLst>
+                          </p:cTn>
+                        </p:par>
+                      </p:childTnLst>
+                    </p:cTn>
+                  </p:par>
+                  <p:par>
+                    <p:cTn id="21" fill="hold">
+                      <p:stCondLst>
+                        <p:cond delay="indefinite"/>
+                      </p:stCondLst>
+                      <p:childTnLst>
+                        <p:par>
+                          <p:cTn id="22" fill="hold">
+                            <p:stCondLst>
+                              <p:cond delay="0"/>
+                            </p:stCondLst>
+                            <p:childTnLst>
+                              <p:par>
+                                <p:cTn id="23" presetID="1" presetClass="entr" presetSubtype="0" fill="hold" nodeType="clickEffect">
+                                  <p:stCondLst>
+                                    <p:cond delay="0"/>
+                                  </p:stCondLst>
+                                  <p:childTnLst>
+                                    <p:set>
+                                      <p:cBhvr>
+                                        <p:cTn id="24" dur="1" fill="hold">
+                                          <p:stCondLst>
+                                            <p:cond delay="0"/>
+                                          </p:stCondLst>
+                                        </p:cTn>
+                                        <p:tgtEl>
+                                          <p:spTgt spid="3">
+                                            <p:txEl>
+                                              <p:pRg st="8" end="8"/>
+                                            </p:txEl>
+                                          </p:spTgt>
+                                        </p:tgtEl>
+                                        <p:attrNameLst>
+                                          <p:attrName>style.visibility</p:attrName>
+                                        </p:attrNameLst>
+                                      </p:cBhvr>
+                                      <p:to>
+                                        <p:strVal val="visible"/>
+                                      </p:to>
+                                    </p:set>
+                                  </p:childTnLst>
+                                </p:cTn>
+                              </p:par>
+                              <p:par>
+                                <p:cTn id="25" presetID="1" presetClass="entr" presetSubtype="0" fill="hold" nodeType="withEffect">
+                                  <p:stCondLst>
+                                    <p:cond delay="0"/>
+                                  </p:stCondLst>
+                                  <p:childTnLst>
+                                    <p:set>
+                                      <p:cBhvr>
+                                        <p:cTn id="26" dur="1" fill="hold">
+                                          <p:stCondLst>
+                                            <p:cond delay="0"/>
+                                          </p:stCondLst>
+                                        </p:cTn>
+                                        <p:tgtEl>
+                                          <p:spTgt spid="3">
+                                            <p:txEl>
+                                              <p:pRg st="9" end="9"/>
+                                            </p:txEl>
+                                          </p:spTgt>
+                                        </p:tgtEl>
+                                        <p:attrNameLst>
+                                          <p:attrName>style.visibility</p:attrName>
+                                        </p:attrNameLst>
+                                      </p:cBhvr>
+                                      <p:to>
+                                        <p:strVal val="visible"/>
+                                      </p:to>
+                                    </p:set>
+                                  </p:childTnLst>
+                                </p:cTn>
+                              </p:par>
+                            </p:childTnLst>
+                          </p:cTn>
+                        </p:par>
+                      </p:childTnLst>
+                    </p:cTn>
+                  </p:par>
+                  <p:par>
+                    <p:cTn id="27" fill="hold">
+                      <p:stCondLst>
+                        <p:cond delay="indefinite"/>
+                      </p:stCondLst>
+                      <p:childTnLst>
+                        <p:par>
+                          <p:cTn id="28" fill="hold">
+                            <p:stCondLst>
+                              <p:cond delay="0"/>
+                            </p:stCondLst>
+                            <p:childTnLst>
+                              <p:par>
+                                <p:cTn id="29" presetID="1" presetClass="entr" presetSubtype="0" fill="hold" nodeType="clickEffect">
+                                  <p:stCondLst>
+                                    <p:cond delay="0"/>
+                                  </p:stCondLst>
+                                  <p:childTnLst>
+                                    <p:set>
+                                      <p:cBhvr>
+                                        <p:cTn id="30" dur="1" fill="hold">
+                                          <p:stCondLst>
+                                            <p:cond delay="0"/>
+                                          </p:stCondLst>
+                                        </p:cTn>
+                                        <p:tgtEl>
+                                          <p:spTgt spid="3">
+                                            <p:txEl>
+                                              <p:pRg st="10" end="10"/>
+                                            </p:txEl>
+                                          </p:spTgt>
+                                        </p:tgtEl>
+                                        <p:attrNameLst>
+                                          <p:attrName>style.visibility</p:attrName>
+                                        </p:attrNameLst>
+                                      </p:cBhvr>
+                                      <p:to>
+                                        <p:strVal val="visible"/>
+                                      </p:to>
+                                    </p:set>
+                                  </p:childTnLst>
+                                </p:cTn>
+                              </p:par>
+                            </p:childTnLst>
+                          </p:cTn>
+                        </p:par>
+                      </p:childTnLst>
+                    </p:cTn>
+                  </p:par>
+                </p:childTnLst>
+              </p:cTn>
+              <p:prevCondLst>
+                <p:cond evt="onPrev" delay="0">
+                  <p:tgtEl>
+                    <p:sldTgt/>
+                  </p:tgtEl>
+                </p:cond>
+              </p:prevCondLst>
+              <p:nextCondLst>
+                <p:cond evt="onNext" delay="0">
+                  <p:tgtEl>
+                    <p:sldTgt/>
+                  </p:tgtEl>
+                </p:cond>
+              </p:nextCondLst>
+            </p:seq>
+          </p:childTnLst>
+        </p:cTn>
+      </p:par>
+    </p:tnLst>
+  </p:timing>
+</p:sld>
+</file>
+
+<file path=ppt/slides/slide5.xml><?xml version="1.0" encoding="utf-8"?>
+<p:sld xmlns:a="http://schemas.openxmlformats.org/drawingml/2006/main" xmlns:r="http://schemas.openxmlformats.org/officeDocument/2006/relationships" xmlns:p="http://schemas.openxmlformats.org/presentationml/2006/main">
+  <p:cSld>
+    <p:spTree>
+      <p:nvGrpSpPr>
+        <p:cNvPr id="1" name=""/>
+        <p:cNvGrpSpPr/>
+        <p:nvPr/>
+      </p:nvGrpSpPr>
+      <p:grpSpPr>
+        <a:xfrm>
+          <a:off x="0" y="0"/>
+          <a:ext cx="0" cy="0"/>
+          <a:chOff x="0" y="0"/>
+          <a:chExt cx="0" cy="0"/>
+        </a:xfrm>
+      </p:grpSpPr>
+      <p:sp>
+        <p:nvSpPr>
+          <p:cNvPr id="2" name="Title 1">
+            <a:extLst>
+              <a:ext uri="{FF2B5EF4-FFF2-40B4-BE49-F238E27FC236}">
                 <a16:creationId xmlns:a16="http://schemas.microsoft.com/office/drawing/2014/main" id="{7FFA545A-4524-828D-6AC3-04DC46925043}"/>
               </a:ext>
             </a:extLst>
@@ -7025,8 +8031,8 @@
           </a:p>
         </p:txBody>
       </p:sp>
-      <mc:AlternateContent xmlns:mc="http://schemas.openxmlformats.org/markup-compatibility/2006">
-        <mc:Choice xmlns:a14="http://schemas.microsoft.com/office/drawing/2010/main" Requires="a14">
+      <mc:AlternateContent xmlns:mc="http://schemas.openxmlformats.org/markup-compatibility/2006" xmlns:a14="http://schemas.microsoft.com/office/drawing/2010/main">
+        <mc:Choice Requires="a14">
           <p:sp>
             <p:nvSpPr>
               <p:cNvPr id="8" name="TextBox 7">
@@ -7055,6 +8061,7 @@
               </a:bodyPr>
               <a:lstStyle/>
               <a:p>
+                <a:pPr/>
                 <a14:m>
                   <m:oMathPara xmlns:m="http://schemas.openxmlformats.org/officeDocument/2006/math">
                     <m:oMathParaPr>
@@ -7178,7 +8185,7 @@
             </p:txBody>
           </p:sp>
         </mc:Choice>
-        <mc:Fallback>
+        <mc:Fallback xmlns="">
           <p:sp>
             <p:nvSpPr>
               <p:cNvPr id="8" name="TextBox 7">
@@ -7526,7 +8533,7 @@
 </p:sld>
 </file>
 
-<file path=ppt/slides/slide5.xml><?xml version="1.0" encoding="utf-8"?>
+<file path=ppt/slides/slide6.xml><?xml version="1.0" encoding="utf-8"?>
 <p:sld xmlns:a="http://schemas.openxmlformats.org/drawingml/2006/main" xmlns:r="http://schemas.openxmlformats.org/officeDocument/2006/relationships" xmlns:p="http://schemas.openxmlformats.org/presentationml/2006/main">
   <p:cSld>
     <p:spTree>
@@ -7577,8 +8584,8 @@
           </a:p>
         </p:txBody>
       </p:sp>
-      <mc:AlternateContent xmlns:mc="http://schemas.openxmlformats.org/markup-compatibility/2006">
-        <mc:Choice xmlns:a14="http://schemas.microsoft.com/office/drawing/2010/main" Requires="a14">
+      <mc:AlternateContent xmlns:mc="http://schemas.openxmlformats.org/markup-compatibility/2006" xmlns:a14="http://schemas.microsoft.com/office/drawing/2010/main">
+        <mc:Choice Requires="a14">
           <p:sp>
             <p:nvSpPr>
               <p:cNvPr id="4" name="TextBox 3">
@@ -7607,6 +8614,7 @@
               </a:bodyPr>
               <a:lstStyle/>
               <a:p>
+                <a:pPr/>
                 <a14:m>
                   <m:oMathPara xmlns:m="http://schemas.openxmlformats.org/officeDocument/2006/math">
                     <m:oMathParaPr>
@@ -7699,7 +8707,7 @@
             </p:txBody>
           </p:sp>
         </mc:Choice>
-        <mc:Fallback>
+        <mc:Fallback xmlns="">
           <p:sp>
             <p:nvSpPr>
               <p:cNvPr id="4" name="TextBox 3">
@@ -7779,8 +8787,8 @@
           </a:p>
         </p:txBody>
       </p:sp>
-      <mc:AlternateContent xmlns:mc="http://schemas.openxmlformats.org/markup-compatibility/2006">
-        <mc:Choice xmlns:a14="http://schemas.microsoft.com/office/drawing/2010/main" Requires="a14">
+      <mc:AlternateContent xmlns:mc="http://schemas.openxmlformats.org/markup-compatibility/2006" xmlns:a14="http://schemas.microsoft.com/office/drawing/2010/main">
+        <mc:Choice Requires="a14">
           <p:sp>
             <p:nvSpPr>
               <p:cNvPr id="15" name="TextBox 14">
@@ -7809,6 +8817,7 @@
               </a:bodyPr>
               <a:lstStyle/>
               <a:p>
+                <a:pPr/>
                 <a14:m>
                   <m:oMathPara xmlns:m="http://schemas.openxmlformats.org/officeDocument/2006/math">
                     <m:oMathParaPr>
@@ -7930,7 +8939,7 @@
             </p:txBody>
           </p:sp>
         </mc:Choice>
-        <mc:Fallback>
+        <mc:Fallback xmlns="">
           <p:sp>
             <p:nvSpPr>
               <p:cNvPr id="15" name="TextBox 14">
@@ -7975,8 +8984,8 @@
           </p:sp>
         </mc:Fallback>
       </mc:AlternateContent>
-      <mc:AlternateContent xmlns:mc="http://schemas.openxmlformats.org/markup-compatibility/2006">
-        <mc:Choice xmlns:a14="http://schemas.microsoft.com/office/drawing/2010/main" Requires="a14">
+      <mc:AlternateContent xmlns:mc="http://schemas.openxmlformats.org/markup-compatibility/2006" xmlns:a14="http://schemas.microsoft.com/office/drawing/2010/main">
+        <mc:Choice Requires="a14">
           <p:sp>
             <p:nvSpPr>
               <p:cNvPr id="16" name="TextBox 15">
@@ -8064,7 +9073,7 @@
             </p:txBody>
           </p:sp>
         </mc:Choice>
-        <mc:Fallback>
+        <mc:Fallback xmlns="">
           <p:sp>
             <p:nvSpPr>
               <p:cNvPr id="16" name="TextBox 15">
@@ -8109,8 +9118,8 @@
           </p:sp>
         </mc:Fallback>
       </mc:AlternateContent>
-      <mc:AlternateContent xmlns:mc="http://schemas.openxmlformats.org/markup-compatibility/2006">
-        <mc:Choice xmlns:a14="http://schemas.microsoft.com/office/drawing/2010/main" Requires="a14">
+      <mc:AlternateContent xmlns:mc="http://schemas.openxmlformats.org/markup-compatibility/2006" xmlns:a14="http://schemas.microsoft.com/office/drawing/2010/main">
+        <mc:Choice Requires="a14">
           <p:sp>
             <p:nvSpPr>
               <p:cNvPr id="17" name="TextBox 16">
@@ -8403,7 +9412,7 @@
             </p:txBody>
           </p:sp>
         </mc:Choice>
-        <mc:Fallback>
+        <mc:Fallback xmlns="">
           <p:sp>
             <p:nvSpPr>
               <p:cNvPr id="17" name="TextBox 16">
@@ -8448,8 +9457,8 @@
           </p:sp>
         </mc:Fallback>
       </mc:AlternateContent>
-      <mc:AlternateContent xmlns:mc="http://schemas.openxmlformats.org/markup-compatibility/2006">
-        <mc:Choice xmlns:a14="http://schemas.microsoft.com/office/drawing/2010/main" Requires="a14">
+      <mc:AlternateContent xmlns:mc="http://schemas.openxmlformats.org/markup-compatibility/2006" xmlns:a14="http://schemas.microsoft.com/office/drawing/2010/main">
+        <mc:Choice Requires="a14">
           <p:sp>
             <p:nvSpPr>
               <p:cNvPr id="18" name="TextBox 17">
@@ -8639,7 +9648,7 @@
             </p:txBody>
           </p:sp>
         </mc:Choice>
-        <mc:Fallback>
+        <mc:Fallback xmlns="">
           <p:sp>
             <p:nvSpPr>
               <p:cNvPr id="18" name="TextBox 17">
@@ -8734,8 +9743,8 @@
             </a:prstGeom>
           </p:spPr>
         </p:pic>
-        <mc:AlternateContent xmlns:mc="http://schemas.openxmlformats.org/markup-compatibility/2006">
-          <mc:Choice xmlns:a14="http://schemas.microsoft.com/office/drawing/2010/main" Requires="a14">
+        <mc:AlternateContent xmlns:mc="http://schemas.openxmlformats.org/markup-compatibility/2006" xmlns:a14="http://schemas.microsoft.com/office/drawing/2010/main">
+          <mc:Choice Requires="a14">
             <p:sp>
               <p:nvSpPr>
                 <p:cNvPr id="21" name="TextBox 20">
@@ -8764,6 +9773,7 @@
                 </a:bodyPr>
                 <a:lstStyle/>
                 <a:p>
+                  <a:pPr/>
                   <a14:m>
                     <m:oMathPara xmlns:m="http://schemas.openxmlformats.org/officeDocument/2006/math">
                       <m:oMathParaPr>
@@ -8832,7 +9842,7 @@
               </p:txBody>
             </p:sp>
           </mc:Choice>
-          <mc:Fallback>
+          <mc:Fallback xmlns="">
             <p:sp>
               <p:nvSpPr>
                 <p:cNvPr id="21" name="TextBox 20">
@@ -9009,8 +10019,8 @@
               <a:chExt cx="5273208" cy="984052"/>
             </a:xfrm>
           </p:grpSpPr>
-          <mc:AlternateContent xmlns:mc="http://schemas.openxmlformats.org/markup-compatibility/2006">
-            <mc:Choice xmlns:a14="http://schemas.microsoft.com/office/drawing/2010/main" Requires="a14">
+          <mc:AlternateContent xmlns:mc="http://schemas.openxmlformats.org/markup-compatibility/2006" xmlns:a14="http://schemas.microsoft.com/office/drawing/2010/main">
+            <mc:Choice Requires="a14">
               <p:sp>
                 <p:nvSpPr>
                   <p:cNvPr id="29" name="TextBox 28">
@@ -9039,6 +10049,7 @@
                   </a:bodyPr>
                   <a:lstStyle/>
                   <a:p>
+                    <a:pPr/>
                     <a14:m>
                       <m:oMathPara xmlns:m="http://schemas.openxmlformats.org/officeDocument/2006/math">
                         <m:oMathParaPr>
@@ -9325,7 +10336,7 @@
                 </p:txBody>
               </p:sp>
             </mc:Choice>
-            <mc:Fallback>
+            <mc:Fallback xmlns="">
               <p:sp>
                 <p:nvSpPr>
                   <p:cNvPr id="29" name="TextBox 28">
@@ -9370,8 +10381,8 @@
               </p:sp>
             </mc:Fallback>
           </mc:AlternateContent>
-          <mc:AlternateContent xmlns:mc="http://schemas.openxmlformats.org/markup-compatibility/2006">
-            <mc:Choice xmlns:a14="http://schemas.microsoft.com/office/drawing/2010/main" Requires="a14">
+          <mc:AlternateContent xmlns:mc="http://schemas.openxmlformats.org/markup-compatibility/2006" xmlns:a14="http://schemas.microsoft.com/office/drawing/2010/main">
+            <mc:Choice Requires="a14">
               <p:sp>
                 <p:nvSpPr>
                   <p:cNvPr id="30" name="TextBox 29">
@@ -9400,6 +10411,7 @@
                   </a:bodyPr>
                   <a:lstStyle/>
                   <a:p>
+                    <a:pPr/>
                     <a14:m>
                       <m:oMathPara xmlns:m="http://schemas.openxmlformats.org/officeDocument/2006/math">
                         <m:oMathParaPr>
@@ -9491,7 +10503,7 @@
                 </p:txBody>
               </p:sp>
             </mc:Choice>
-            <mc:Fallback>
+            <mc:Fallback xmlns="">
               <p:sp>
                 <p:nvSpPr>
                   <p:cNvPr id="30" name="TextBox 29">
@@ -9536,8 +10548,8 @@
               </p:sp>
             </mc:Fallback>
           </mc:AlternateContent>
-          <mc:AlternateContent xmlns:mc="http://schemas.openxmlformats.org/markup-compatibility/2006">
-            <mc:Choice xmlns:a14="http://schemas.microsoft.com/office/drawing/2010/main" Requires="a14">
+          <mc:AlternateContent xmlns:mc="http://schemas.openxmlformats.org/markup-compatibility/2006" xmlns:a14="http://schemas.microsoft.com/office/drawing/2010/main">
+            <mc:Choice Requires="a14">
               <p:sp>
                 <p:nvSpPr>
                   <p:cNvPr id="31" name="TextBox 30">
@@ -9566,6 +10578,7 @@
                   </a:bodyPr>
                   <a:lstStyle/>
                   <a:p>
+                    <a:pPr/>
                     <a14:m>
                       <m:oMathPara xmlns:m="http://schemas.openxmlformats.org/officeDocument/2006/math">
                         <m:oMathParaPr>
@@ -9764,7 +10777,7 @@
                 </p:txBody>
               </p:sp>
             </mc:Choice>
-            <mc:Fallback>
+            <mc:Fallback xmlns="">
               <p:sp>
                 <p:nvSpPr>
                   <p:cNvPr id="31" name="TextBox 30">
@@ -9809,8 +10822,8 @@
               </p:sp>
             </mc:Fallback>
           </mc:AlternateContent>
-          <mc:AlternateContent xmlns:mc="http://schemas.openxmlformats.org/markup-compatibility/2006">
-            <mc:Choice xmlns:a14="http://schemas.microsoft.com/office/drawing/2010/main" Requires="a14">
+          <mc:AlternateContent xmlns:mc="http://schemas.openxmlformats.org/markup-compatibility/2006" xmlns:a14="http://schemas.microsoft.com/office/drawing/2010/main">
+            <mc:Choice Requires="a14">
               <p:sp>
                 <p:nvSpPr>
                   <p:cNvPr id="32" name="TextBox 31">
@@ -10050,7 +11063,7 @@
                 </p:txBody>
               </p:sp>
             </mc:Choice>
-            <mc:Fallback>
+            <mc:Fallback xmlns="">
               <p:sp>
                 <p:nvSpPr>
                   <p:cNvPr id="32" name="TextBox 31">

</xml_diff>

<commit_message>
Fix bug in calculation of transfer functions
</commit_message>
<xml_diff>
--- a/docs/Generating LRI CRNs.pptx
+++ b/docs/Generating LRI CRNs.pptx
@@ -8742,8 +8742,8 @@
         </p:nvSpPr>
         <p:spPr>
           <a:xfrm>
-            <a:off x="8128000" y="1690688"/>
-            <a:ext cx="2007281" cy="369332"/>
+            <a:off x="7771162" y="1690688"/>
+            <a:ext cx="3709477" cy="369332"/>
           </a:xfrm>
           <a:prstGeom prst="rect">
             <a:avLst/>
@@ -8758,7 +8758,7 @@
           <a:p>
             <a:r>
               <a:rPr lang="en-US" b="1" dirty="0"/>
-              <a:t>General expression</a:t>
+              <a:t>General expression for step response</a:t>
             </a:r>
           </a:p>
         </p:txBody>
@@ -9647,236 +9647,6 @@
       </mc:AlternateContent>
       <p:grpSp>
         <p:nvGrpSpPr>
-          <p:cNvPr id="24" name="Group 23">
-            <a:extLst>
-              <a:ext uri="{FF2B5EF4-FFF2-40B4-BE49-F238E27FC236}">
-                <a16:creationId xmlns:a16="http://schemas.microsoft.com/office/drawing/2014/main" id="{0C41D7E4-0C58-EE71-EF9D-3729F2B52E39}"/>
-              </a:ext>
-            </a:extLst>
-          </p:cNvPr>
-          <p:cNvGrpSpPr/>
-          <p:nvPr/>
-        </p:nvGrpSpPr>
-        <p:grpSpPr>
-          <a:xfrm>
-            <a:off x="6768284" y="3128225"/>
-            <a:ext cx="5041402" cy="2433082"/>
-            <a:chOff x="6768284" y="3128225"/>
-            <a:chExt cx="5041402" cy="2433082"/>
-          </a:xfrm>
-        </p:grpSpPr>
-        <p:pic>
-          <p:nvPicPr>
-            <p:cNvPr id="20" name="Picture 19">
-              <a:extLst>
-                <a:ext uri="{FF2B5EF4-FFF2-40B4-BE49-F238E27FC236}">
-                  <a16:creationId xmlns:a16="http://schemas.microsoft.com/office/drawing/2014/main" id="{7191DD5E-D9C9-55E8-0441-089F9683BCD0}"/>
-                </a:ext>
-              </a:extLst>
-            </p:cNvPr>
-            <p:cNvPicPr>
-              <a:picLocks noChangeAspect="1"/>
-            </p:cNvPicPr>
-            <p:nvPr/>
-          </p:nvPicPr>
-          <p:blipFill>
-            <a:blip r:embed="rId7"/>
-            <a:stretch>
-              <a:fillRect/>
-            </a:stretch>
-          </p:blipFill>
-          <p:spPr>
-            <a:xfrm>
-              <a:off x="7523436" y="3497557"/>
-              <a:ext cx="4286250" cy="2063750"/>
-            </a:xfrm>
-            <a:prstGeom prst="rect">
-              <a:avLst/>
-            </a:prstGeom>
-          </p:spPr>
-        </p:pic>
-        <mc:AlternateContent xmlns:mc="http://schemas.openxmlformats.org/markup-compatibility/2006" xmlns:a14="http://schemas.microsoft.com/office/drawing/2010/main">
-          <mc:Choice Requires="a14">
-            <p:sp>
-              <p:nvSpPr>
-                <p:cNvPr id="21" name="TextBox 20">
-                  <a:extLst>
-                    <a:ext uri="{FF2B5EF4-FFF2-40B4-BE49-F238E27FC236}">
-                      <a16:creationId xmlns:a16="http://schemas.microsoft.com/office/drawing/2014/main" id="{E1425D66-768E-2661-CE2D-B4B91D1E9807}"/>
-                    </a:ext>
-                  </a:extLst>
-                </p:cNvPr>
-                <p:cNvSpPr txBox="1"/>
-                <p:nvPr/>
-              </p:nvSpPr>
-              <p:spPr>
-                <a:xfrm>
-                  <a:off x="6768284" y="4261989"/>
-                  <a:ext cx="919291" cy="520463"/>
-                </a:xfrm>
-                <a:prstGeom prst="rect">
-                  <a:avLst/>
-                </a:prstGeom>
-                <a:noFill/>
-              </p:spPr>
-              <p:txBody>
-                <a:bodyPr wrap="none" lIns="0" tIns="0" rIns="0" bIns="0" rtlCol="0">
-                  <a:spAutoFit/>
-                </a:bodyPr>
-                <a:lstStyle/>
-                <a:p>
-                  <a:pPr/>
-                  <a14:m>
-                    <m:oMathPara xmlns:m="http://schemas.openxmlformats.org/officeDocument/2006/math">
-                      <m:oMathParaPr>
-                        <m:jc m:val="centerGroup"/>
-                      </m:oMathParaPr>
-                      <m:oMath xmlns:m="http://schemas.openxmlformats.org/officeDocument/2006/math">
-                        <m:r>
-                          <a:rPr lang="en-US" b="1" i="1" smtClean="0">
-                            <a:latin typeface="Cambria Math" panose="02040503050406030204" pitchFamily="18" charset="0"/>
-                          </a:rPr>
-                          <m:t>𝒙</m:t>
-                        </m:r>
-                        <m:d>
-                          <m:dPr>
-                            <m:ctrlPr>
-                              <a:rPr lang="en-US" b="0" i="1" smtClean="0">
-                                <a:latin typeface="Cambria Math" panose="02040503050406030204" pitchFamily="18" charset="0"/>
-                              </a:rPr>
-                            </m:ctrlPr>
-                          </m:dPr>
-                          <m:e>
-                            <m:r>
-                              <a:rPr lang="en-US" b="0" i="1" smtClean="0">
-                                <a:latin typeface="Cambria Math" panose="02040503050406030204" pitchFamily="18" charset="0"/>
-                              </a:rPr>
-                              <m:t>𝑠</m:t>
-                            </m:r>
-                          </m:e>
-                        </m:d>
-                        <m:r>
-                          <a:rPr lang="en-US" b="0" i="1" smtClean="0">
-                            <a:latin typeface="Cambria Math" panose="02040503050406030204" pitchFamily="18" charset="0"/>
-                          </a:rPr>
-                          <m:t>=</m:t>
-                        </m:r>
-                        <m:f>
-                          <m:fPr>
-                            <m:ctrlPr>
-                              <a:rPr lang="en-US" b="0" i="1" smtClean="0">
-                                <a:latin typeface="Cambria Math" panose="02040503050406030204" pitchFamily="18" charset="0"/>
-                              </a:rPr>
-                            </m:ctrlPr>
-                          </m:fPr>
-                          <m:num>
-                            <m:r>
-                              <a:rPr lang="en-US" b="0" i="1" smtClean="0">
-                                <a:latin typeface="Cambria Math" panose="02040503050406030204" pitchFamily="18" charset="0"/>
-                              </a:rPr>
-                              <m:t>1</m:t>
-                            </m:r>
-                          </m:num>
-                          <m:den>
-                            <m:r>
-                              <a:rPr lang="en-US" b="0" i="1" smtClean="0">
-                                <a:latin typeface="Cambria Math" panose="02040503050406030204" pitchFamily="18" charset="0"/>
-                              </a:rPr>
-                              <m:t>𝑠</m:t>
-                            </m:r>
-                          </m:den>
-                        </m:f>
-                      </m:oMath>
-                    </m:oMathPara>
-                  </a14:m>
-                  <a:endParaRPr lang="en-US" dirty="0"/>
-                </a:p>
-              </p:txBody>
-            </p:sp>
-          </mc:Choice>
-          <mc:Fallback xmlns="">
-            <p:sp>
-              <p:nvSpPr>
-                <p:cNvPr id="21" name="TextBox 20">
-                  <a:extLst>
-                    <a:ext uri="{FF2B5EF4-FFF2-40B4-BE49-F238E27FC236}">
-                      <a16:creationId xmlns:a16="http://schemas.microsoft.com/office/drawing/2014/main" id="{E1425D66-768E-2661-CE2D-B4B91D1E9807}"/>
-                    </a:ext>
-                  </a:extLst>
-                </p:cNvPr>
-                <p:cNvSpPr txBox="1">
-                  <a:spLocks noRot="1" noChangeAspect="1" noMove="1" noResize="1" noEditPoints="1" noAdjustHandles="1" noChangeArrowheads="1" noChangeShapeType="1" noTextEdit="1"/>
-                </p:cNvSpPr>
-                <p:nvPr/>
-              </p:nvSpPr>
-              <p:spPr>
-                <a:xfrm>
-                  <a:off x="6768284" y="4261989"/>
-                  <a:ext cx="919291" cy="520463"/>
-                </a:xfrm>
-                <a:prstGeom prst="rect">
-                  <a:avLst/>
-                </a:prstGeom>
-                <a:blipFill>
-                  <a:blip r:embed="rId8"/>
-                  <a:stretch>
-                    <a:fillRect l="-2703" t="-4762" r="-5405" b="-9524"/>
-                  </a:stretch>
-                </a:blipFill>
-              </p:spPr>
-              <p:txBody>
-                <a:bodyPr/>
-                <a:lstStyle/>
-                <a:p>
-                  <a:r>
-                    <a:rPr lang="en-US">
-                      <a:noFill/>
-                    </a:rPr>
-                    <a:t> </a:t>
-                  </a:r>
-                </a:p>
-              </p:txBody>
-            </p:sp>
-          </mc:Fallback>
-        </mc:AlternateContent>
-        <p:sp>
-          <p:nvSpPr>
-            <p:cNvPr id="23" name="TextBox 22">
-              <a:extLst>
-                <a:ext uri="{FF2B5EF4-FFF2-40B4-BE49-F238E27FC236}">
-                  <a16:creationId xmlns:a16="http://schemas.microsoft.com/office/drawing/2014/main" id="{C79CC97D-36CA-3A6E-E150-5C3DAF85077E}"/>
-                </a:ext>
-              </a:extLst>
-            </p:cNvPr>
-            <p:cNvSpPr txBox="1"/>
-            <p:nvPr/>
-          </p:nvSpPr>
-          <p:spPr>
-            <a:xfrm>
-              <a:off x="8128000" y="3128225"/>
-              <a:ext cx="2171364" cy="369332"/>
-            </a:xfrm>
-            <a:prstGeom prst="rect">
-              <a:avLst/>
-            </a:prstGeom>
-            <a:noFill/>
-          </p:spPr>
-          <p:txBody>
-            <a:bodyPr wrap="none" rtlCol="0">
-              <a:spAutoFit/>
-            </a:bodyPr>
-            <a:lstStyle/>
-            <a:p>
-              <a:r>
-                <a:rPr lang="en-US" b="1" dirty="0"/>
-                <a:t>Solution for example</a:t>
-              </a:r>
-            </a:p>
-          </p:txBody>
-        </p:sp>
-      </p:grpSp>
-      <p:grpSp>
-        <p:nvGrpSpPr>
           <p:cNvPr id="25" name="Group 24">
             <a:extLst>
               <a:ext uri="{FF2B5EF4-FFF2-40B4-BE49-F238E27FC236}">
@@ -9890,9 +9660,9 @@
         <p:grpSpPr>
           <a:xfrm>
             <a:off x="477866" y="1528384"/>
-            <a:ext cx="5287317" cy="1863447"/>
+            <a:ext cx="5978690" cy="1863447"/>
             <a:chOff x="6417633" y="1381790"/>
-            <a:chExt cx="5287317" cy="1863447"/>
+            <a:chExt cx="5513558" cy="1863447"/>
           </a:xfrm>
         </p:grpSpPr>
         <p:sp>
@@ -9910,7 +9680,7 @@
           <p:spPr>
             <a:xfrm>
               <a:off x="6463821" y="1778429"/>
-              <a:ext cx="5241129" cy="1466808"/>
+              <a:ext cx="5467370" cy="1466808"/>
             </a:xfrm>
             <a:prstGeom prst="rect">
               <a:avLst/>
@@ -9966,9 +9736,9 @@
           <p:grpSpPr>
             <a:xfrm>
               <a:off x="6417633" y="1993126"/>
-              <a:ext cx="5262057" cy="984052"/>
+              <a:ext cx="5250906" cy="984052"/>
               <a:chOff x="4088521" y="2906030"/>
-              <a:chExt cx="5262057" cy="984052"/>
+              <a:chExt cx="5250906" cy="984052"/>
             </a:xfrm>
           </p:grpSpPr>
           <mc:AlternateContent xmlns:mc="http://schemas.openxmlformats.org/markup-compatibility/2006" xmlns:a14="http://schemas.microsoft.com/office/drawing/2010/main">
@@ -10349,8 +10119,8 @@
                 </p:nvSpPr>
                 <p:spPr>
                   <a:xfrm>
-                    <a:off x="8819746" y="3015099"/>
-                    <a:ext cx="530832" cy="765915"/>
+                    <a:off x="8808595" y="3059703"/>
+                    <a:ext cx="530832" cy="743858"/>
                   </a:xfrm>
                   <a:prstGeom prst="rect">
                     <a:avLst/>
@@ -10370,6 +10140,31 @@
                           <m:jc m:val="centerGroup"/>
                         </m:oMathParaPr>
                         <m:oMath xmlns:m="http://schemas.openxmlformats.org/officeDocument/2006/math">
+                          <m:f>
+                            <m:fPr>
+                              <m:ctrlPr>
+                                <a:rPr lang="en-US" b="0" i="1" smtClean="0">
+                                  <a:latin typeface="Cambria Math" panose="02040503050406030204" pitchFamily="18" charset="0"/>
+                                </a:rPr>
+                              </m:ctrlPr>
+                            </m:fPr>
+                            <m:num>
+                              <m:r>
+                                <a:rPr lang="en-US" b="0" i="1" smtClean="0">
+                                  <a:latin typeface="Cambria Math" panose="02040503050406030204" pitchFamily="18" charset="0"/>
+                                </a:rPr>
+                                <m:t>1</m:t>
+                              </m:r>
+                            </m:num>
+                            <m:den>
+                              <m:r>
+                                <a:rPr lang="en-US" b="0" i="1" smtClean="0">
+                                  <a:latin typeface="Cambria Math" panose="02040503050406030204" pitchFamily="18" charset="0"/>
+                                </a:rPr>
+                                <m:t>𝑠</m:t>
+                              </m:r>
+                            </m:den>
+                          </m:f>
                           <m:d>
                             <m:dPr>
                               <m:ctrlPr>
@@ -10472,8 +10267,8 @@
                 </p:nvSpPr>
                 <p:spPr>
                   <a:xfrm>
-                    <a:off x="8819746" y="3015099"/>
-                    <a:ext cx="530832" cy="765915"/>
+                    <a:off x="8808595" y="3059703"/>
+                    <a:ext cx="530832" cy="743858"/>
                   </a:xfrm>
                   <a:prstGeom prst="rect">
                     <a:avLst/>
@@ -10481,7 +10276,7 @@
                   <a:blipFill>
                     <a:blip r:embed="rId10"/>
                     <a:stretch>
-                      <a:fillRect t="-1639" b="-6557"/>
+                      <a:fillRect l="-15217" r="-15217" b="-8333"/>
                     </a:stretch>
                   </a:blipFill>
                 </p:spPr>
@@ -11481,6 +11276,352 @@
           </p:sp>
         </mc:Fallback>
       </mc:AlternateContent>
+      <p:grpSp>
+        <p:nvGrpSpPr>
+          <p:cNvPr id="8" name="Group 7">
+            <a:extLst>
+              <a:ext uri="{FF2B5EF4-FFF2-40B4-BE49-F238E27FC236}">
+                <a16:creationId xmlns:a16="http://schemas.microsoft.com/office/drawing/2014/main" id="{49A0D302-3831-34A3-236D-768294715D7E}"/>
+              </a:ext>
+            </a:extLst>
+          </p:cNvPr>
+          <p:cNvGrpSpPr/>
+          <p:nvPr/>
+        </p:nvGrpSpPr>
+        <p:grpSpPr>
+          <a:xfrm>
+            <a:off x="6768284" y="3128225"/>
+            <a:ext cx="5041402" cy="2433082"/>
+            <a:chOff x="6768284" y="3128225"/>
+            <a:chExt cx="5041402" cy="2433082"/>
+          </a:xfrm>
+        </p:grpSpPr>
+        <p:pic>
+          <p:nvPicPr>
+            <p:cNvPr id="20" name="Picture 19">
+              <a:extLst>
+                <a:ext uri="{FF2B5EF4-FFF2-40B4-BE49-F238E27FC236}">
+                  <a16:creationId xmlns:a16="http://schemas.microsoft.com/office/drawing/2014/main" id="{7191DD5E-D9C9-55E8-0441-089F9683BCD0}"/>
+                </a:ext>
+              </a:extLst>
+            </p:cNvPr>
+            <p:cNvPicPr>
+              <a:picLocks noChangeAspect="1"/>
+            </p:cNvPicPr>
+            <p:nvPr/>
+          </p:nvPicPr>
+          <p:blipFill>
+            <a:blip r:embed="rId15"/>
+            <a:stretch>
+              <a:fillRect/>
+            </a:stretch>
+          </p:blipFill>
+          <p:spPr>
+            <a:xfrm>
+              <a:off x="7523436" y="3497557"/>
+              <a:ext cx="4286250" cy="2063750"/>
+            </a:xfrm>
+            <a:prstGeom prst="rect">
+              <a:avLst/>
+            </a:prstGeom>
+          </p:spPr>
+        </p:pic>
+        <mc:AlternateContent xmlns:mc="http://schemas.openxmlformats.org/markup-compatibility/2006">
+          <mc:Choice xmlns:a14="http://schemas.microsoft.com/office/drawing/2010/main" Requires="a14">
+            <p:sp>
+              <p:nvSpPr>
+                <p:cNvPr id="21" name="TextBox 20">
+                  <a:extLst>
+                    <a:ext uri="{FF2B5EF4-FFF2-40B4-BE49-F238E27FC236}">
+                      <a16:creationId xmlns:a16="http://schemas.microsoft.com/office/drawing/2014/main" id="{E1425D66-768E-2661-CE2D-B4B91D1E9807}"/>
+                    </a:ext>
+                  </a:extLst>
+                </p:cNvPr>
+                <p:cNvSpPr txBox="1"/>
+                <p:nvPr/>
+              </p:nvSpPr>
+              <p:spPr>
+                <a:xfrm>
+                  <a:off x="6768284" y="4261989"/>
+                  <a:ext cx="919291" cy="520463"/>
+                </a:xfrm>
+                <a:prstGeom prst="rect">
+                  <a:avLst/>
+                </a:prstGeom>
+                <a:noFill/>
+              </p:spPr>
+              <p:txBody>
+                <a:bodyPr wrap="none" lIns="0" tIns="0" rIns="0" bIns="0" rtlCol="0">
+                  <a:spAutoFit/>
+                </a:bodyPr>
+                <a:lstStyle/>
+                <a:p>
+                  <a:pPr/>
+                  <a14:m>
+                    <m:oMathPara xmlns:m="http://schemas.openxmlformats.org/officeDocument/2006/math">
+                      <m:oMathParaPr>
+                        <m:jc m:val="centerGroup"/>
+                      </m:oMathParaPr>
+                      <m:oMath xmlns:m="http://schemas.openxmlformats.org/officeDocument/2006/math">
+                        <m:r>
+                          <a:rPr lang="en-US" b="1" i="1" smtClean="0">
+                            <a:latin typeface="Cambria Math" panose="02040503050406030204" pitchFamily="18" charset="0"/>
+                          </a:rPr>
+                          <m:t>𝒙</m:t>
+                        </m:r>
+                        <m:d>
+                          <m:dPr>
+                            <m:ctrlPr>
+                              <a:rPr lang="en-US" b="0" i="1" smtClean="0">
+                                <a:latin typeface="Cambria Math" panose="02040503050406030204" pitchFamily="18" charset="0"/>
+                              </a:rPr>
+                            </m:ctrlPr>
+                          </m:dPr>
+                          <m:e>
+                            <m:r>
+                              <a:rPr lang="en-US" b="0" i="1" smtClean="0">
+                                <a:latin typeface="Cambria Math" panose="02040503050406030204" pitchFamily="18" charset="0"/>
+                              </a:rPr>
+                              <m:t>𝑠</m:t>
+                            </m:r>
+                          </m:e>
+                        </m:d>
+                        <m:r>
+                          <a:rPr lang="en-US" b="0" i="1" smtClean="0">
+                            <a:latin typeface="Cambria Math" panose="02040503050406030204" pitchFamily="18" charset="0"/>
+                          </a:rPr>
+                          <m:t>=</m:t>
+                        </m:r>
+                        <m:f>
+                          <m:fPr>
+                            <m:ctrlPr>
+                              <a:rPr lang="en-US" b="0" i="1" smtClean="0">
+                                <a:latin typeface="Cambria Math" panose="02040503050406030204" pitchFamily="18" charset="0"/>
+                              </a:rPr>
+                            </m:ctrlPr>
+                          </m:fPr>
+                          <m:num>
+                            <m:r>
+                              <a:rPr lang="en-US" b="0" i="1" smtClean="0">
+                                <a:latin typeface="Cambria Math" panose="02040503050406030204" pitchFamily="18" charset="0"/>
+                              </a:rPr>
+                              <m:t>1</m:t>
+                            </m:r>
+                          </m:num>
+                          <m:den>
+                            <m:r>
+                              <a:rPr lang="en-US" b="0" i="1" smtClean="0">
+                                <a:latin typeface="Cambria Math" panose="02040503050406030204" pitchFamily="18" charset="0"/>
+                              </a:rPr>
+                              <m:t>𝑠</m:t>
+                            </m:r>
+                          </m:den>
+                        </m:f>
+                      </m:oMath>
+                    </m:oMathPara>
+                  </a14:m>
+                  <a:endParaRPr lang="en-US" dirty="0"/>
+                </a:p>
+              </p:txBody>
+            </p:sp>
+          </mc:Choice>
+          <mc:Fallback>
+            <p:sp>
+              <p:nvSpPr>
+                <p:cNvPr id="21" name="TextBox 20">
+                  <a:extLst>
+                    <a:ext uri="{FF2B5EF4-FFF2-40B4-BE49-F238E27FC236}">
+                      <a16:creationId xmlns:a16="http://schemas.microsoft.com/office/drawing/2014/main" id="{E1425D66-768E-2661-CE2D-B4B91D1E9807}"/>
+                    </a:ext>
+                  </a:extLst>
+                </p:cNvPr>
+                <p:cNvSpPr txBox="1">
+                  <a:spLocks noRot="1" noChangeAspect="1" noMove="1" noResize="1" noEditPoints="1" noAdjustHandles="1" noChangeArrowheads="1" noChangeShapeType="1" noTextEdit="1"/>
+                </p:cNvSpPr>
+                <p:nvPr/>
+              </p:nvSpPr>
+              <p:spPr>
+                <a:xfrm>
+                  <a:off x="6768284" y="4261989"/>
+                  <a:ext cx="919291" cy="520463"/>
+                </a:xfrm>
+                <a:prstGeom prst="rect">
+                  <a:avLst/>
+                </a:prstGeom>
+                <a:blipFill>
+                  <a:blip r:embed="rId16"/>
+                  <a:stretch>
+                    <a:fillRect l="-2703" t="-4762" r="-5405" b="-9524"/>
+                  </a:stretch>
+                </a:blipFill>
+              </p:spPr>
+              <p:txBody>
+                <a:bodyPr/>
+                <a:lstStyle/>
+                <a:p>
+                  <a:r>
+                    <a:rPr lang="en-US">
+                      <a:noFill/>
+                    </a:rPr>
+                    <a:t> </a:t>
+                  </a:r>
+                </a:p>
+              </p:txBody>
+            </p:sp>
+          </mc:Fallback>
+        </mc:AlternateContent>
+        <p:sp>
+          <p:nvSpPr>
+            <p:cNvPr id="23" name="TextBox 22">
+              <a:extLst>
+                <a:ext uri="{FF2B5EF4-FFF2-40B4-BE49-F238E27FC236}">
+                  <a16:creationId xmlns:a16="http://schemas.microsoft.com/office/drawing/2014/main" id="{C79CC97D-36CA-3A6E-E150-5C3DAF85077E}"/>
+                </a:ext>
+              </a:extLst>
+            </p:cNvPr>
+            <p:cNvSpPr txBox="1"/>
+            <p:nvPr/>
+          </p:nvSpPr>
+          <p:spPr>
+            <a:xfrm>
+              <a:off x="8128000" y="3128225"/>
+              <a:ext cx="2717411" cy="369332"/>
+            </a:xfrm>
+            <a:prstGeom prst="rect">
+              <a:avLst/>
+            </a:prstGeom>
+            <a:noFill/>
+          </p:spPr>
+          <p:txBody>
+            <a:bodyPr wrap="none" rtlCol="0">
+              <a:spAutoFit/>
+            </a:bodyPr>
+            <a:lstStyle/>
+            <a:p>
+              <a:r>
+                <a:rPr lang="en-US" b="1" dirty="0"/>
+                <a:t>Step response for example</a:t>
+              </a:r>
+            </a:p>
+          </p:txBody>
+        </p:sp>
+        <mc:AlternateContent xmlns:mc="http://schemas.openxmlformats.org/markup-compatibility/2006">
+          <mc:Choice xmlns:a14="http://schemas.microsoft.com/office/drawing/2010/main" Requires="a14">
+            <p:sp>
+              <p:nvSpPr>
+                <p:cNvPr id="7" name="TextBox 6">
+                  <a:extLst>
+                    <a:ext uri="{FF2B5EF4-FFF2-40B4-BE49-F238E27FC236}">
+                      <a16:creationId xmlns:a16="http://schemas.microsoft.com/office/drawing/2014/main" id="{B739EBCB-4D0D-6DAE-6869-C338027D6FFA}"/>
+                    </a:ext>
+                  </a:extLst>
+                </p:cNvPr>
+                <p:cNvSpPr txBox="1"/>
+                <p:nvPr/>
+              </p:nvSpPr>
+              <p:spPr>
+                <a:xfrm>
+                  <a:off x="9517560" y="3618568"/>
+                  <a:ext cx="281552" cy="276999"/>
+                </a:xfrm>
+                <a:prstGeom prst="rect">
+                  <a:avLst/>
+                </a:prstGeom>
+                <a:solidFill>
+                  <a:schemeClr val="bg1"/>
+                </a:solidFill>
+              </p:spPr>
+              <p:txBody>
+                <a:bodyPr wrap="none" lIns="0" tIns="0" rIns="0" bIns="0" rtlCol="0">
+                  <a:spAutoFit/>
+                </a:bodyPr>
+                <a:lstStyle/>
+                <a:p>
+                  <a14:m>
+                    <m:oMathPara xmlns:m="http://schemas.openxmlformats.org/officeDocument/2006/math">
+                      <m:oMathParaPr>
+                        <m:jc m:val="centerGroup"/>
+                      </m:oMathParaPr>
+                      <m:oMath xmlns:m="http://schemas.openxmlformats.org/officeDocument/2006/math">
+                        <m:sSub>
+                          <m:sSubPr>
+                            <m:ctrlPr>
+                              <a:rPr lang="en-US" b="0" i="1" smtClean="0">
+                                <a:latin typeface="Cambria Math" panose="02040503050406030204" pitchFamily="18" charset="0"/>
+                              </a:rPr>
+                            </m:ctrlPr>
+                          </m:sSubPr>
+                          <m:e>
+                            <m:r>
+                              <a:rPr lang="en-US" b="0" i="1" smtClean="0">
+                                <a:latin typeface="Cambria Math" panose="02040503050406030204" pitchFamily="18" charset="0"/>
+                              </a:rPr>
+                              <m:t>𝑘</m:t>
+                            </m:r>
+                          </m:e>
+                          <m:sub>
+                            <m:r>
+                              <a:rPr lang="en-US" b="0" i="1" smtClean="0">
+                                <a:latin typeface="Cambria Math" panose="02040503050406030204" pitchFamily="18" charset="0"/>
+                              </a:rPr>
+                              <m:t>1</m:t>
+                            </m:r>
+                          </m:sub>
+                        </m:sSub>
+                      </m:oMath>
+                    </m:oMathPara>
+                  </a14:m>
+                  <a:endParaRPr lang="en-US" dirty="0"/>
+                </a:p>
+              </p:txBody>
+            </p:sp>
+          </mc:Choice>
+          <mc:Fallback>
+            <p:sp>
+              <p:nvSpPr>
+                <p:cNvPr id="7" name="TextBox 6">
+                  <a:extLst>
+                    <a:ext uri="{FF2B5EF4-FFF2-40B4-BE49-F238E27FC236}">
+                      <a16:creationId xmlns:a16="http://schemas.microsoft.com/office/drawing/2014/main" id="{B739EBCB-4D0D-6DAE-6869-C338027D6FFA}"/>
+                    </a:ext>
+                  </a:extLst>
+                </p:cNvPr>
+                <p:cNvSpPr txBox="1">
+                  <a:spLocks noRot="1" noChangeAspect="1" noMove="1" noResize="1" noEditPoints="1" noAdjustHandles="1" noChangeArrowheads="1" noChangeShapeType="1" noTextEdit="1"/>
+                </p:cNvSpPr>
+                <p:nvPr/>
+              </p:nvSpPr>
+              <p:spPr>
+                <a:xfrm>
+                  <a:off x="9517560" y="3618568"/>
+                  <a:ext cx="281552" cy="276999"/>
+                </a:xfrm>
+                <a:prstGeom prst="rect">
+                  <a:avLst/>
+                </a:prstGeom>
+                <a:blipFill>
+                  <a:blip r:embed="rId17"/>
+                  <a:stretch>
+                    <a:fillRect l="-21739" r="-4348" b="-18182"/>
+                  </a:stretch>
+                </a:blipFill>
+              </p:spPr>
+              <p:txBody>
+                <a:bodyPr/>
+                <a:lstStyle/>
+                <a:p>
+                  <a:r>
+                    <a:rPr lang="en-US">
+                      <a:noFill/>
+                    </a:rPr>
+                    <a:t> </a:t>
+                  </a:r>
+                </a:p>
+              </p:txBody>
+            </p:sp>
+          </mc:Fallback>
+        </mc:AlternateContent>
+      </p:grpSp>
     </p:spTree>
     <p:extLst>
       <p:ext uri="{BB962C8B-B14F-4D97-AF65-F5344CB8AC3E}">
@@ -11737,7 +11878,7 @@
                             </p:stCondLst>
                             <p:childTnLst>
                               <p:par>
-                                <p:cTn id="23" presetID="1" presetClass="entr" presetSubtype="0" fill="hold" nodeType="clickEffect">
+                                <p:cTn id="23" presetID="1" presetClass="entr" presetSubtype="0" fill="hold" grpId="0" nodeType="clickEffect">
                                   <p:stCondLst>
                                     <p:cond delay="0"/>
                                   </p:stCondLst>
@@ -11750,7 +11891,7 @@
                                           </p:stCondLst>
                                         </p:cTn>
                                         <p:tgtEl>
-                                          <p:spTgt spid="24"/>
+                                          <p:spTgt spid="18"/>
                                         </p:tgtEl>
                                         <p:attrNameLst>
                                           <p:attrName>style.visibility</p:attrName>
@@ -11782,7 +11923,7 @@
                             </p:stCondLst>
                             <p:childTnLst>
                               <p:par>
-                                <p:cTn id="27" presetID="1" presetClass="entr" presetSubtype="0" fill="hold" grpId="0" nodeType="clickEffect">
+                                <p:cTn id="27" presetID="1" presetClass="entr" presetSubtype="0" fill="hold" nodeType="clickEffect">
                                   <p:stCondLst>
                                     <p:cond delay="0"/>
                                   </p:stCondLst>
@@ -11795,7 +11936,7 @@
                                           </p:stCondLst>
                                         </p:cTn>
                                         <p:tgtEl>
-                                          <p:spTgt spid="18"/>
+                                          <p:spTgt spid="8"/>
                                         </p:tgtEl>
                                         <p:attrNameLst>
                                           <p:attrName>style.visibility</p:attrName>

</xml_diff>